<commit_message>
chore: regenerate the exercise decks from the renamed HTML guides
Co-Authored-By: Claude Opus 5 (1M context) <noreply@anthropic.com>
</commit_message>
<xml_diff>
--- a/guides-pptx/spryker-academy-fundamental.pptx
+++ b/guides-pptx/spryker-academy-fundamental.pptx
@@ -4330,7 +4330,7 @@
               </a:defRPr>
             </a:pPr>
             <a:r>
-              <a:t>Open src/SprykerAcademy/Shared/ContactRequest/Transfer/contact_request.transfer.xml and add a DTO named ContactRequestResponse with: - Property message of type Message - Property isSuccessful of type bool</a:t>
+              <a:t>Open src/SprykerAcademy/Shared/ContactRequest/Transfer/contact_request.transfer.xml and add a DTO named ContactRequestResponse with: - Property contactRequest of type ContactRequest - Property isSuccessful of type bool</a:t>
             </a:r>
           </a:p>
           <a:p>
@@ -5253,7 +5253,7 @@
               </a:defRPr>
             </a:pPr>
             <a:r>
-              <a:t>The controller passes message (a ContactRequestTransfer ) to the template. Access object properties with dot notation: objectName.objectProperty .</a:t>
+              <a:t>The controller passes contactRequest (a ContactRequestTransfer ) to the template. Access object properties with dot notation: objectName.objectProperty .</a:t>
             </a:r>
           </a:p>
         </p:txBody>
@@ -5402,7 +5402,7 @@
               </a:defRPr>
             </a:pPr>
             <a:r>
-              <a:t>Open src/SprykerAcademy/Zed/ContactRequest/Presentation/Index/add.twig . Replace the placeholder 'show-message-name-here' with the actual message value using dot notation ( message.message ).</a:t>
+              <a:t>Open src/SprykerAcademy/Zed/ContactRequest/Presentation/Index/add.twig . Replace the placeholder 'show-contact-request-message-here' with the message of the contact request using dot notation ( contactRequest.message ).</a:t>
             </a:r>
           </a:p>
           <a:p>
@@ -7240,7 +7240,7 @@
               </a:defRPr>
             </a:pPr>
             <a:r>
-              <a:t>Part 2 of 2 - This guide focuses on showing the message in Yves.</a:t>
+              <a:t>Part 2 of 2 - This guide focuses on showing the contact request in Yves.</a:t>
             </a:r>
           </a:p>
         </p:txBody>
@@ -8809,7 +8809,7 @@
               </a:defRPr>
             </a:pPr>
             <a:r>
-              <a:t>Open src/SprykerAcademy/Client/ContactRequest/ContactRequestClient.php . Complete findContactRequest() by using the factory to create a ContactRequestStub and return the found message.</a:t>
+              <a:t>Open src/SprykerAcademy/Client/ContactRequest/ContactRequestClient.php . Complete findContactRequest() by using the factory to create a ContactRequestStub and return the found contact request.</a:t>
             </a:r>
           </a:p>
           <a:p>
@@ -9588,7 +9588,7 @@
               </a:defRPr>
             </a:pPr>
             <a:r>
-              <a:t>The template is already provided at src/SprykerAcademy/Yves/ContactRequestPage/Theme/default/views/contact-request/get.twig and expects a variable named message .</a:t>
+              <a:t>The template is already provided at src/SprykerAcademy/Yves/ContactRequestPage/Theme/default/views/contact-request/get.twig and expects a variable named contactRequest .</a:t>
             </a:r>
           </a:p>
           <a:p>
@@ -9618,7 +9618,7 @@
               </a:defRPr>
             </a:pPr>
             <a:r>
-              <a:t>Open src/SprykerAcademy/Yves/ContactRequestPage/Controller/IndexController.php . Complete getAction() : 1. Instantiate a ContactRequestCriteriaTransfer and set the message ID from the route parameter 2. Use getFactory() to access the ContactRequestClient 3. Find a message by the criteria and assign the result to $contactRequestResponseTransfer</a:t>
+              <a:t>Open src/SprykerAcademy/Yves/ContactRequestPage/Controller/IndexController.php . Complete getAction() : 1. Instantiate a ContactRequestCriteriaTransfer and set the contact request ID ( idContactRequest ) from the route parameter 2. Use getFactory() to access the ContactRequestClient 3. Find a contact request by the criteria and assign the result to $contactRequestResponseTransfer</a:t>
             </a:r>
           </a:p>
           <a:p>
@@ -9800,7 +9800,7 @@
               </a:defRPr>
             </a:pPr>
             <a:r>
-              <a:t>Open src/SprykerAcademy/Yves/ContactRequestPage/Plugin/Router/ContactRequestPageRouteProviderPlugin.php . In addContactRequestMessageGetRoute() , fill in the correct module name and controller name for the placeholders.</a:t>
+              <a:t>Open src/SprykerAcademy/Yves/ContactRequestPage/Plugin/Router/ContactRequestPageRouteProviderPlugin.php . In addContactRequestGetRoute() , fill in the correct module name and controller name for the placeholders.</a:t>
             </a:r>
           </a:p>
           <a:p>
@@ -9964,7 +9964,7 @@
               </a:defRPr>
             </a:pPr>
             <a:r>
-              <a:t>• Create a message via Back Office: http://backoffice.eu.spryker.local/contact-request/index/add</a:t>
+              <a:t>• Create a contact request via Back Office: http://backoffice.eu.spryker.local/contact-request/index/add</a:t>
             </a:r>
           </a:p>
           <a:p>
@@ -9979,7 +9979,7 @@
               </a:defRPr>
             </a:pPr>
             <a:r>
-              <a:t>• View the message in Yves using its ID: http://yves.eu.spryker.local/contact-request/1</a:t>
+              <a:t>• View the contact request in Yves using its idContactRequest : http://yves.eu.spryker.local/contact-request/1</a:t>
             </a:r>
           </a:p>
         </p:txBody>
@@ -19580,7 +19580,7 @@
                 </a:solidFill>
                 <a:latin typeface="Consolas"/>
               </a:rPr>
-              <a:t>   (table pyz_contact_request, namespace Orm\Zed\Message\Persistence). Run docker/sdk console propel:install.</a:t>
+              <a:t>   (table pyz_contact_request, namespace Orm\Zed\ContactRequest\Persistence). Run docker/sdk console propel:install.</a:t>
             </a:r>
           </a:p>
           <a:p>
@@ -19927,7 +19927,7 @@
                 </a:solidFill>
                 <a:latin typeface="Consolas"/>
               </a:rPr>
-              <a:t>   /contact-request/{idContactRequest} (route name contact-request/message/_idMessage_).</a:t>
+              <a:t>   /contact-request/{idContactRequest} (route parameter `idContactRequest`).</a:t>
             </a:r>
           </a:p>
           <a:p>
@@ -22835,7 +22835,7 @@
               </a:defRPr>
             </a:pPr>
             <a:r>
-              <a:t>• Add a fkCustomer property of type int to the Message transfer</a:t>
+              <a:t>• Add a fkCustomer property of type int to the ContactRequest transfer</a:t>
             </a:r>
           </a:p>
           <a:p>
@@ -22850,7 +22850,7 @@
               </a:defRPr>
             </a:pPr>
             <a:r>
-              <a:t>• Add a createdAt property of type string to the Message transfer</a:t>
+              <a:t>• Add a createdAt property of type string to the ContactRequest transfer</a:t>
             </a:r>
           </a:p>
           <a:p>
@@ -22880,7 +22880,7 @@
               </a:defRPr>
             </a:pPr>
             <a:r>
-              <a:t>• Add a new transfer named ContactRequestCollection with a property messages of type Message[]</a:t>
+              <a:t>• Add a new transfer named ContactRequestCollection with a property contactRequests of type ContactRequest[]</a:t>
             </a:r>
           </a:p>
           <a:p>
@@ -27016,7 +27016,7 @@
               </a:defRPr>
             </a:pPr>
             <a:r>
-              <a:t>• Use $this-&gt;castId($request-&gt;request-&gt;get('idContactRequest')) to safely extract and validate the message ID</a:t>
+              <a:t>• Use $this-&gt;castId($request-&gt;request-&gt;get('idContactRequest')) to safely extract and validate the contact request ID</a:t>
             </a:r>
           </a:p>
         </p:txBody>
@@ -27843,7 +27843,7 @@
                 </a:solidFill>
                 <a:latin typeface="Consolas"/>
               </a:rPr>
-              <a:t>            url: path('customer/messages'),</a:t>
+              <a:t>            url: path('customer/contact-requests'),</a:t>
             </a:r>
           </a:p>
           <a:p>
@@ -28034,7 +28034,7 @@
               </a:defRPr>
             </a:pPr>
             <a:r>
-              <a:t>❝ customer/messages is the route name ( ContactRequestController::ROUTE_CUSTOMER_CONTACT_REQUESTS ), not the path. Add the item only after the route is registered, otherwise path() fails on every account page. When you load the complete branch, the loader adds this item for you (between {# &gt;&gt;&gt; contact-request exercise #} markers) and removes it again when you load another branch.</a:t>
+              <a:t>❝ customer/contact-requests is the route name ( ContactRequestController::ROUTE_CUSTOMER_CONTACT_REQUESTS ), not the path. Add the item only after the route is registered, otherwise path() fails on every account page. When you load the complete branch, the loader adds this item for you (between {# &gt;&gt;&gt; contact-request exercise #} markers) and removes it again when you load another branch.</a:t>
             </a:r>
           </a:p>
           <a:p>
@@ -31706,7 +31706,7 @@
                 </a:solidFill>
                 <a:latin typeface="Consolas"/>
               </a:rPr>
-              <a:t>{% include molecule('ajax-form-submitter') with { attributes: { 'trigger-attribute': 'data-message-ajax-submit', 'provider-class-name': ajaxProviderClass } } only %}</a:t>
+              <a:t>{% include molecule('ajax-form-submitter') with { attributes: { 'trigger-attribute': 'data-contact-request-ajax-submit', 'provider-class-name': ajaxProviderClass } } only %}</a:t>
             </a:r>
           </a:p>
           <a:p>
@@ -31721,7 +31721,7 @@
               </a:defRPr>
             </a:pPr>
             <a:r>
-              <a:t>Form buttons use data-message-ajax-submit and formaction to point to the async endpoint:</a:t>
+              <a:t>Form buttons use data-contact-request-ajax-submit and formaction to point to the async endpoint:</a:t>
             </a:r>
           </a:p>
           <a:p>
@@ -31749,7 +31749,7 @@
                 </a:solidFill>
                 <a:latin typeface="Consolas"/>
               </a:rPr>
-              <a:t> data-message-ajax-submit formaction=</a:t>
+              <a:t> data-contact-request-ajax-submit formaction=</a:t>
             </a:r>
             <a:r>
               <a:rPr sz="900">
@@ -31813,7 +31813,7 @@
                 </a:solidFill>
                 <a:latin typeface="Consolas"/>
               </a:rPr>
-              <a:t> data-message-ajax-submit formaction=</a:t>
+              <a:t> data-contact-request-ajax-submit formaction=</a:t>
             </a:r>
             <a:r>
               <a:rPr sz="900">
@@ -31983,7 +31983,7 @@
               </a:defRPr>
             </a:pPr>
             <a:r>
-              <a:t>• MessageAsyncController — addAction() and deleteAction() return JsonResponse instead of redirects</a:t>
+              <a:t>• ContactRequestAsyncController — addAction() and deleteAction() return JsonResponse instead of redirects</a:t>
             </a:r>
           </a:p>
           <a:p>
@@ -32013,7 +32013,7 @@
               </a:defRPr>
             </a:pPr>
             <a:r>
-              <a:t>• message-async.twig — Content fragment re-rendered server-side after each operation</a:t>
+              <a:t>• contact-request-async.twig — Content fragment re-rendered server-side after each operation</a:t>
             </a:r>
           </a:p>
           <a:p>
@@ -32979,7 +32979,7 @@
                 </a:solidFill>
                 <a:latin typeface="Consolas"/>
               </a:rPr>
-              <a:t>"Message"</a:t>
+              <a:t>"ContactRequest"</a:t>
             </a:r>
             <a:r>
               <a:rPr sz="900" b="1">
@@ -33699,7 +33699,7 @@
                 </a:solidFill>
                 <a:latin typeface="Consolas"/>
               </a:rPr>
-              <a:t>"message"</a:t>
+              <a:t>"contactRequest"</a:t>
             </a:r>
             <a:r>
               <a:rPr sz="900">
@@ -33717,7 +33717,7 @@
                 </a:solidFill>
                 <a:latin typeface="Consolas"/>
               </a:rPr>
-              <a:t>"Message"</a:t>
+              <a:t>"ContactRequest"</a:t>
             </a:r>
             <a:r>
               <a:rPr sz="900" b="1">
@@ -39658,7 +39658,7 @@
                 </a:solidFill>
                 <a:latin typeface="Consolas"/>
               </a:rPr>
-              <a:t>'@ContactRequestPage/views/message/get.twig'</a:t>
+              <a:t>'@ContactRequestPage/views/contact-request/get.twig'</a:t>
             </a:r>
             <a:r>
               <a:rPr sz="900">
@@ -40895,7 +40895,7 @@
                 </a:solidFill>
                 <a:latin typeface="Consolas"/>
               </a:rPr>
-              <a:t>'/contact-request/gateway/find-message'</a:t>
+              <a:t>'/contact-request/gateway/find-contact-request'</a:t>
             </a:r>
             <a:r>
               <a:rPr sz="900">
@@ -41508,7 +41508,7 @@
               </a:defRPr>
             </a:pPr>
             <a:r>
-              <a:t>Gateway URL convention: /contact-request/gateway/find-message maps to ContactRequest module -&gt; GatewayController -&gt; findContactRequestAction() . Transfers are serialized/deserialized automatically.</a:t>
+              <a:t>Gateway URL convention: /contact-request/gateway/find-contact-request maps to ContactRequest module -&gt; GatewayController -&gt; findContactRequestAction() . Transfers are serialized/deserialized automatically.</a:t>
             </a:r>
           </a:p>
         </p:txBody>
@@ -62938,7 +62938,7 @@
                 </a:solidFill>
                 <a:latin typeface="Consolas"/>
               </a:rPr>
-              <a:t>      -&gt; ZedRequestClient::call('/contact-request/gateway/find-message', $transfer)</a:t>
+              <a:t>      -&gt; ZedRequestClient::call('/contact-request/gateway/find-contact-request', $transfer)</a:t>
             </a:r>
           </a:p>
           <a:p>
@@ -64566,7 +64566,7 @@
               </a:defRPr>
             </a:pPr>
             <a:r>
-              <a:t>Verify the pyz_contact_request table was created in the database (using a tool of your choice). Locate the generated entity in src/Orm/Zed/Message/Persistence/ and its subfolders.</a:t>
+              <a:t>Verify the pyz_contact_request table was created in the database (using a tool of your choice). Locate the generated entity in src/Orm/Zed/ContactRequest/Persistence/ and its subfolders.</a:t>
             </a:r>
           </a:p>
         </p:txBody>

</xml_diff>

<commit_message>
docs: match guide 07 to the rebuilt skeleton, and name the new facade test
Guide 07 Part 1 was missing the unique-index change the complete branch
makes, so a student following it could not save two contact requests with
the same text from different customers. The "provided scaffolding" list
also did not mention the Deleter or castId(), which the exercise hands over
finished.

Guide 04 now says that the Facade step is covered by a test.

Co-Authored-By: Claude Opus 5 (1M context) <noreply@anthropic.com>
</commit_message>
<xml_diff>
--- a/guides-pptx/spryker-academy-fundamental.pptx
+++ b/guides-pptx/spryker-academy-fundamental.pptx
@@ -211,6 +211,7 @@
     <p:sldId id="459" r:id="rId210"/>
     <p:sldId id="460" r:id="rId211"/>
     <p:sldId id="461" r:id="rId212"/>
+    <p:sldId id="462" r:id="rId213"/>
   </p:sldIdLst>
   <p:sldSz cx="12191695" cy="6858000" type="screen4x3"/>
   <p:notesSz cx="6858000" cy="9144000"/>
@@ -7826,6 +7827,21 @@
               <a:t>Hint: The Writer returns a ContactRequestTransfer ; the Reader returns a ContactRequestResponseTransfer . No Business Factory is needed — the container injects ContactRequestEntityManagerInterface into the Writer and ContactRequestRepositoryInterface into the Reader automatically.</a:t>
             </a:r>
           </a:p>
+          <a:p>
+            <a:pPr>
+              <a:spcAft>
+                <a:spcPts val="800"/>
+              </a:spcAft>
+              <a:defRPr sz="1600">
+                <a:solidFill>
+                  <a:srgbClr val="1A1A1A"/>
+                </a:solidFill>
+              </a:defRPr>
+            </a:pPr>
+            <a:r>
+              <a:t>ContactRequestFacadeTest checks this step: it mocks the Writer and the Reader and asserts the Facade hands their result back, so leaving either method empty fails the suite.</a:t>
+            </a:r>
+          </a:p>
         </p:txBody>
       </p:sp>
     </p:spTree>
@@ -8959,7 +8975,7 @@
               </a:defRPr>
             </a:pPr>
             <a:r>
-              <a:t>This tests the ContactRequestReader and ContactRequestWriter business logic. All tests should pass if your implementation is correct.</a:t>
+              <a:t>This tests the ContactRequestReader, the ContactRequestWriter and the ContactRequestFacade. All tests should pass if your implementation is correct.</a:t>
             </a:r>
           </a:p>
         </p:txBody>
@@ -25051,7 +25067,7 @@
               </a:defRPr>
             </a:pPr>
             <a:r>
-              <a:t>Open src/SprykerAcademy/Zed/ContactRequest/Persistence/Propel/Schema/pyz_contact_request.schema.xml and: 1. Add a new column fk_customer of type INTEGER (not required, since existing messages have no customer) 2. Add a &lt;foreign-key&gt; element that references the spy_customer table, mapping fk_customer to id_customer with onDelete="CASCADE" 3. Add &lt;behavior name="timestampable"/&gt; — Propel will auto-add created_at and updated_at TIMESTAMP columns</a:t>
+              <a:t>Open src/SprykerAcademy/Zed/ContactRequest/Persistence/Propel/Schema/pyz_contact_request.schema.xml and: 1. Add a new column fk_customer of type INTEGER (not required, since existing contact requests have no customer) 2. Add fk_customer to the existing pyz_contact_request-message unique index, so two customers can send the same text 3. Add a &lt;foreign-key&gt; element that references the spy_customer table, mapping fk_customer to id_customer with onDelete="CASCADE" 4. Add &lt;behavior name="timestampable"/&gt; — Propel will auto-add created_at and updated_at TIMESTAMP columns</a:t>
             </a:r>
           </a:p>
           <a:p>
@@ -29560,40 +29576,37 @@
               </a:defRPr>
             </a:pPr>
             <a:r>
-              <a:t>• src/SprykerAcademy/Yves/CustomerPage/Theme/.../views/contact-request/list.twig — The Twig template showing the message table with delete buttons and the add form</a:t>
-            </a:r>
-          </a:p>
-          <a:p>
-            <a:pPr>
-              <a:spcAft>
-                <a:spcPts val="800"/>
-              </a:spcAft>
-              <a:defRPr sz="1600">
+              <a:t>• src/SprykerAcademy/Yves/CustomerPage/Theme/.../views/contact-request/list.twig — The Twig template showing the contact request table with delete buttons and the add form</a:t>
+            </a:r>
+          </a:p>
+          <a:p>
+            <a:pPr>
+              <a:spcAft>
+                <a:spcPts val="400"/>
+              </a:spcAft>
+              <a:defRPr sz="1500">
                 <a:solidFill>
                   <a:srgbClr val="1A1A1A"/>
                 </a:solidFill>
               </a:defRPr>
             </a:pPr>
             <a:r>
-              <a:t>Take a moment to review these files to understand: - How Spryker’s template override mechanism works (project-level Twig overrides vendor templates by matching the file path) - How the form is rendered with form_start / form_widget / form_end (Symfony form rendering helpers) - How each table row has a mini POST form for the delete button (no link — delete is always POST)</a:t>
-            </a:r>
-          </a:p>
-          <a:p>
-            <a:pPr>
-              <a:spcBef>
-                <a:spcPts val="800"/>
-              </a:spcBef>
+              <a:t>• src/SprykerAcademy/Zed/ContactRequest/Business/Deleter/ContactRequestDeleter.php and the Facade’s deleteContactRequest() — the delete business model, so Part 4 has something to call</a:t>
+            </a:r>
+          </a:p>
+          <a:p>
+            <a:pPr>
               <a:spcAft>
                 <a:spcPts val="400"/>
               </a:spcAft>
-              <a:defRPr sz="1700" b="1">
+              <a:defRPr sz="1500">
                 <a:solidFill>
                   <a:srgbClr val="1A1A1A"/>
                 </a:solidFill>
               </a:defRPr>
             </a:pPr>
             <a:r>
-              <a:t>6.7 Sidebar Menu Item</a:t>
+              <a:t>• ContactRequestController::castId() — the numeric-id guard described in 6.4</a:t>
             </a:r>
           </a:p>
         </p:txBody>
@@ -29727,121 +29740,40 @@
               </a:defRPr>
             </a:pPr>
             <a:r>
+              <a:t>Take a moment to review these files to understand: - How Spryker’s template override mechanism works (project-level Twig overrides vendor templates by matching the file path) - How the form is rendered with form_start / form_widget / form_end (Symfony form rendering helpers) - How each table row has a mini POST form for the delete button (no link — delete is always POST)</a:t>
+            </a:r>
+          </a:p>
+          <a:p>
+            <a:pPr>
+              <a:spcBef>
+                <a:spcPts val="800"/>
+              </a:spcBef>
+              <a:spcAft>
+                <a:spcPts val="400"/>
+              </a:spcAft>
+              <a:defRPr sz="1700" b="1">
+                <a:solidFill>
+                  <a:srgbClr val="1A1A1A"/>
+                </a:solidFill>
+              </a:defRPr>
+            </a:pPr>
+            <a:r>
+              <a:t>6.7 Sidebar Menu Item</a:t>
+            </a:r>
+          </a:p>
+          <a:p>
+            <a:pPr>
+              <a:spcAft>
+                <a:spcPts val="800"/>
+              </a:spcAft>
+              <a:defRPr sz="1600">
+                <a:solidFill>
+                  <a:srgbClr val="1A1A1A"/>
+                </a:solidFill>
+              </a:defRPr>
+            </a:pPr>
+            <a:r>
               <a:t>Once the route exists, add a “My Contact Requests” entry to the customer account sidebar. The project overrides that molecule in src/Pyz/Yves/CustomerPage/Theme/default/components/molecules/navigation-sidebar/navigation-sidebar.twig ; append one more entry to its items array:</a:t>
-            </a:r>
-          </a:p>
-          <a:p>
-            <a:pPr>
-              <a:spcBef>
-                <a:spcPts val="0"/>
-              </a:spcBef>
-              <a:spcAft>
-                <a:spcPts val="0"/>
-              </a:spcAft>
-            </a:pPr>
-            <a:r>
-              <a:rPr sz="900">
-                <a:solidFill>
-                  <a:srgbClr val="2D2D2D"/>
-                </a:solidFill>
-                <a:latin typeface="Consolas"/>
-              </a:rPr>
-              <a:t>        {</a:t>
-            </a:r>
-          </a:p>
-          <a:p>
-            <a:pPr>
-              <a:spcBef>
-                <a:spcPts val="0"/>
-              </a:spcBef>
-              <a:spcAft>
-                <a:spcPts val="0"/>
-              </a:spcAft>
-            </a:pPr>
-            <a:r>
-              <a:rPr sz="900">
-                <a:solidFill>
-                  <a:srgbClr val="2D2D2D"/>
-                </a:solidFill>
-                <a:latin typeface="Consolas"/>
-              </a:rPr>
-              <a:t>            name: 'contact-requests',</a:t>
-            </a:r>
-          </a:p>
-          <a:p>
-            <a:pPr>
-              <a:spcBef>
-                <a:spcPts val="0"/>
-              </a:spcBef>
-              <a:spcAft>
-                <a:spcPts val="0"/>
-              </a:spcAft>
-            </a:pPr>
-            <a:r>
-              <a:rPr sz="900">
-                <a:solidFill>
-                  <a:srgbClr val="2D2D2D"/>
-                </a:solidFill>
-                <a:latin typeface="Consolas"/>
-              </a:rPr>
-              <a:t>            url: path('customer/contact-requests'),</a:t>
-            </a:r>
-          </a:p>
-          <a:p>
-            <a:pPr>
-              <a:spcBef>
-                <a:spcPts val="0"/>
-              </a:spcBef>
-              <a:spcAft>
-                <a:spcPts val="0"/>
-              </a:spcAft>
-            </a:pPr>
-            <a:r>
-              <a:rPr sz="900">
-                <a:solidFill>
-                  <a:srgbClr val="2D2D2D"/>
-                </a:solidFill>
-                <a:latin typeface="Consolas"/>
-              </a:rPr>
-              <a:t>            label: 'My Contact Requests',</a:t>
-            </a:r>
-          </a:p>
-          <a:p>
-            <a:pPr>
-              <a:spcBef>
-                <a:spcPts val="0"/>
-              </a:spcBef>
-              <a:spcAft>
-                <a:spcPts val="0"/>
-              </a:spcAft>
-            </a:pPr>
-            <a:r>
-              <a:rPr sz="900">
-                <a:solidFill>
-                  <a:srgbClr val="2D2D2D"/>
-                </a:solidFill>
-                <a:latin typeface="Consolas"/>
-              </a:rPr>
-              <a:t>            icon: 'envelopes',</a:t>
-            </a:r>
-          </a:p>
-          <a:p>
-            <a:pPr>
-              <a:spcBef>
-                <a:spcPts val="0"/>
-              </a:spcBef>
-              <a:spcAft>
-                <a:spcPts val="0"/>
-              </a:spcAft>
-            </a:pPr>
-            <a:r>
-              <a:rPr sz="900">
-                <a:solidFill>
-                  <a:srgbClr val="2D2D2D"/>
-                </a:solidFill>
-                <a:latin typeface="Consolas"/>
-              </a:rPr>
-              <a:t>        },</a:t>
             </a:r>
           </a:p>
         </p:txBody>
@@ -29965,88 +29897,116 @@
           <a:lstStyle/>
           <a:p>
             <a:pPr>
-              <a:spcAft>
-                <a:spcPts val="800"/>
-              </a:spcAft>
-              <a:defRPr sz="1400" i="1">
-                <a:solidFill>
-                  <a:srgbClr val="888888"/>
-                </a:solidFill>
-              </a:defRPr>
-            </a:pPr>
-            <a:r>
-              <a:t>❝ customer/contact-requests is the route name ( ContactRequestController::ROUTE_CUSTOMER_CONTACT_REQUESTS ), not the path. Add the item only after the route is registered, otherwise path() fails on every account page. name is what the sidebar compares against the activePage the list page sets, so it has to read contact-requests for the entry to be highlighted. Do not wrap the entry in a Twig comment: the whole items array lives inside one {% define data = {...} %} tag, and a {# ... #} in there is read as an unclosed { , which kills every account page with a SyntaxError . When you load the complete branch, the loader adds this item for you and removes it again when you load another branch.</a:t>
-            </a:r>
-          </a:p>
-          <a:p>
-            <a:pPr>
-              <a:spcAft>
-                <a:spcPts val="800"/>
-              </a:spcAft>
-              <a:defRPr sz="1600">
-                <a:solidFill>
-                  <a:srgbClr val="1A1A1A"/>
-                </a:solidFill>
-              </a:defRPr>
-            </a:pPr>
-            <a:r>
-              <a:t>Clear cache:</a:t>
-            </a:r>
-          </a:p>
-          <a:p>
-            <a:pPr>
-              <a:spcBef>
-                <a:spcPts val="0"/>
-              </a:spcBef>
-              <a:spcAft>
-                <a:spcPts val="0"/>
-              </a:spcAft>
-            </a:pPr>
-            <a:r>
-              <a:rPr sz="900">
-                <a:solidFill>
-                  <a:srgbClr val="2D2D2D"/>
-                </a:solidFill>
-                <a:latin typeface="Consolas"/>
-              </a:rPr>
-              <a:t>docker/sdk</a:t>
-            </a:r>
-            <a:r>
-              <a:rPr sz="900">
-                <a:solidFill>
-                  <a:srgbClr val="2D2D2D"/>
-                </a:solidFill>
-                <a:latin typeface="Consolas"/>
-              </a:rPr>
-              <a:t> console cache:empty-all</a:t>
-            </a:r>
-          </a:p>
-          <a:p>
-            <a:pPr>
-              <a:spcBef>
-                <a:spcPts val="0"/>
-              </a:spcBef>
-              <a:spcAft>
-                <a:spcPts val="0"/>
-              </a:spcAft>
-            </a:pPr>
-            <a:r>
-              <a:rPr sz="900">
-                <a:solidFill>
-                  <a:srgbClr val="2D2D2D"/>
-                </a:solidFill>
-                <a:latin typeface="Consolas"/>
-              </a:rPr>
-              <a:t>docker/sdk</a:t>
-            </a:r>
-            <a:r>
-              <a:rPr sz="900">
-                <a:solidFill>
-                  <a:srgbClr val="2D2D2D"/>
-                </a:solidFill>
-                <a:latin typeface="Consolas"/>
-              </a:rPr>
-              <a:t> console propel:model:build</a:t>
+              <a:spcBef>
+                <a:spcPts val="0"/>
+              </a:spcBef>
+              <a:spcAft>
+                <a:spcPts val="0"/>
+              </a:spcAft>
+            </a:pPr>
+            <a:r>
+              <a:rPr sz="900">
+                <a:solidFill>
+                  <a:srgbClr val="2D2D2D"/>
+                </a:solidFill>
+                <a:latin typeface="Consolas"/>
+              </a:rPr>
+              <a:t>        {</a:t>
+            </a:r>
+          </a:p>
+          <a:p>
+            <a:pPr>
+              <a:spcBef>
+                <a:spcPts val="0"/>
+              </a:spcBef>
+              <a:spcAft>
+                <a:spcPts val="0"/>
+              </a:spcAft>
+            </a:pPr>
+            <a:r>
+              <a:rPr sz="900">
+                <a:solidFill>
+                  <a:srgbClr val="2D2D2D"/>
+                </a:solidFill>
+                <a:latin typeface="Consolas"/>
+              </a:rPr>
+              <a:t>            name: 'contact-requests',</a:t>
+            </a:r>
+          </a:p>
+          <a:p>
+            <a:pPr>
+              <a:spcBef>
+                <a:spcPts val="0"/>
+              </a:spcBef>
+              <a:spcAft>
+                <a:spcPts val="0"/>
+              </a:spcAft>
+            </a:pPr>
+            <a:r>
+              <a:rPr sz="900">
+                <a:solidFill>
+                  <a:srgbClr val="2D2D2D"/>
+                </a:solidFill>
+                <a:latin typeface="Consolas"/>
+              </a:rPr>
+              <a:t>            url: path('customer/contact-requests'),</a:t>
+            </a:r>
+          </a:p>
+          <a:p>
+            <a:pPr>
+              <a:spcBef>
+                <a:spcPts val="0"/>
+              </a:spcBef>
+              <a:spcAft>
+                <a:spcPts val="0"/>
+              </a:spcAft>
+            </a:pPr>
+            <a:r>
+              <a:rPr sz="900">
+                <a:solidFill>
+                  <a:srgbClr val="2D2D2D"/>
+                </a:solidFill>
+                <a:latin typeface="Consolas"/>
+              </a:rPr>
+              <a:t>            label: 'My Contact Requests',</a:t>
+            </a:r>
+          </a:p>
+          <a:p>
+            <a:pPr>
+              <a:spcBef>
+                <a:spcPts val="0"/>
+              </a:spcBef>
+              <a:spcAft>
+                <a:spcPts val="0"/>
+              </a:spcAft>
+            </a:pPr>
+            <a:r>
+              <a:rPr sz="900">
+                <a:solidFill>
+                  <a:srgbClr val="2D2D2D"/>
+                </a:solidFill>
+                <a:latin typeface="Consolas"/>
+              </a:rPr>
+              <a:t>            icon: 'envelopes',</a:t>
+            </a:r>
+          </a:p>
+          <a:p>
+            <a:pPr>
+              <a:spcBef>
+                <a:spcPts val="0"/>
+              </a:spcBef>
+              <a:spcAft>
+                <a:spcPts val="0"/>
+              </a:spcAft>
+            </a:pPr>
+            <a:r>
+              <a:rPr sz="900">
+                <a:solidFill>
+                  <a:srgbClr val="2D2D2D"/>
+                </a:solidFill>
+                <a:latin typeface="Consolas"/>
+              </a:rPr>
+              <a:t>        },</a:t>
             </a:r>
           </a:p>
         </p:txBody>
@@ -30099,7 +30059,7 @@
               </a:defRPr>
             </a:pPr>
             <a:r>
-              <a:t>Best Practices Applied in This Exercise</a:t>
+              <a:t>Part 6: Extend the CustomerPage Module (cont.)</a:t>
             </a:r>
           </a:p>
         </p:txBody>
@@ -30170,130 +30130,88 @@
           <a:lstStyle/>
           <a:p>
             <a:pPr>
-              <a:spcBef>
-                <a:spcPts val="1200"/>
-              </a:spcBef>
-              <a:spcAft>
-                <a:spcPts val="600"/>
-              </a:spcAft>
-              <a:defRPr sz="2000" b="1">
+              <a:spcAft>
+                <a:spcPts val="800"/>
+              </a:spcAft>
+              <a:defRPr sz="1400" i="1">
+                <a:solidFill>
+                  <a:srgbClr val="888888"/>
+                </a:solidFill>
+              </a:defRPr>
+            </a:pPr>
+            <a:r>
+              <a:t>❝ customer/contact-requests is the route name ( ContactRequestController::ROUTE_CUSTOMER_CONTACT_REQUESTS ), not the path. Add the item only after the route is registered, otherwise path() fails on every account page. name is what the sidebar compares against the activePage the list page sets, so it has to read contact-requests for the entry to be highlighted. Do not wrap the entry in a Twig comment: the whole items array lives inside one {% define data = {...} %} tag, and a {# ... #} in there is read as an unclosed { , which kills every account page with a SyntaxError . When you load the complete branch, the loader adds this item for you and removes it again when you load another branch.</a:t>
+            </a:r>
+          </a:p>
+          <a:p>
+            <a:pPr>
+              <a:spcAft>
+                <a:spcPts val="800"/>
+              </a:spcAft>
+              <a:defRPr sz="1600">
                 <a:solidFill>
                   <a:srgbClr val="1A1A1A"/>
                 </a:solidFill>
               </a:defRPr>
             </a:pPr>
             <a:r>
-              <a:t>SOLID: Single Responsibility for Business Models</a:t>
-            </a:r>
-          </a:p>
-          <a:p>
-            <a:pPr>
-              <a:spcAft>
-                <a:spcPts val="800"/>
-              </a:spcAft>
-              <a:defRPr sz="1600">
-                <a:solidFill>
-                  <a:srgbClr val="1A1A1A"/>
-                </a:solidFill>
-              </a:defRPr>
-            </a:pPr>
-            <a:r>
-              <a:t>The business layer separates concerns into dedicated classes:</a:t>
-            </a:r>
-          </a:p>
-          <a:p>
-            <a:pPr>
-              <a:spcAft>
-                <a:spcPts val="100"/>
-              </a:spcAft>
-              <a:defRPr sz="1000">
-                <a:solidFill>
-                  <a:srgbClr val="1A1A1A"/>
-                </a:solidFill>
-                <a:latin typeface="Consolas"/>
-              </a:defRPr>
-            </a:pPr>
-            <a:r>
-              <a:t>Class                  Responsibility                                   </a:t>
-            </a:r>
-          </a:p>
-          <a:p>
-            <a:pPr>
-              <a:spcAft>
-                <a:spcPts val="100"/>
-              </a:spcAft>
-              <a:defRPr sz="1000">
-                <a:solidFill>
-                  <a:srgbClr val="1A1A1A"/>
-                </a:solidFill>
-                <a:latin typeface="Consolas"/>
-              </a:defRPr>
-            </a:pPr>
-            <a:r>
-              <a:t>---------------------  -------------------------------------------------</a:t>
-            </a:r>
-          </a:p>
-          <a:p>
-            <a:pPr>
-              <a:spcAft>
-                <a:spcPts val="100"/>
-              </a:spcAft>
-              <a:defRPr sz="1000">
-                <a:solidFill>
-                  <a:srgbClr val="1A1A1A"/>
-                </a:solidFill>
-                <a:latin typeface="Consolas"/>
-              </a:defRPr>
-            </a:pPr>
-            <a:r>
-              <a:t>ContactRequestReader   Reading/querying messages (uses Repository)      </a:t>
-            </a:r>
-          </a:p>
-          <a:p>
-            <a:pPr>
-              <a:spcAft>
-                <a:spcPts val="100"/>
-              </a:spcAft>
-              <a:defRPr sz="1000">
-                <a:solidFill>
-                  <a:srgbClr val="1A1A1A"/>
-                </a:solidFill>
-                <a:latin typeface="Consolas"/>
-              </a:defRPr>
-            </a:pPr>
-            <a:r>
-              <a:t>ContactRequestWriter   Creating/persisting messages (uses EntityManager)</a:t>
-            </a:r>
-          </a:p>
-          <a:p>
-            <a:pPr>
-              <a:spcAft>
-                <a:spcPts val="100"/>
-              </a:spcAft>
-              <a:defRPr sz="1000">
-                <a:solidFill>
-                  <a:srgbClr val="1A1A1A"/>
-                </a:solidFill>
-                <a:latin typeface="Consolas"/>
-              </a:defRPr>
-            </a:pPr>
-            <a:r>
-              <a:t>ContactRequestDeleter  Deleting messages (uses EntityManager)</a:t>
-            </a:r>
-          </a:p>
-          <a:p>
-            <a:pPr>
-              <a:spcAft>
-                <a:spcPts val="800"/>
-              </a:spcAft>
-              <a:defRPr sz="1600">
-                <a:solidFill>
-                  <a:srgbClr val="1A1A1A"/>
-                </a:solidFill>
-              </a:defRPr>
-            </a:pPr>
-            <a:r>
-              <a:t>Each class has one reason to change . The Writer does not know how to delete. The Deleter does not know how to create. The Facade orchestrates all three through the BusinessFactory.</a:t>
+              <a:t>Clear cache:</a:t>
+            </a:r>
+          </a:p>
+          <a:p>
+            <a:pPr>
+              <a:spcBef>
+                <a:spcPts val="0"/>
+              </a:spcBef>
+              <a:spcAft>
+                <a:spcPts val="0"/>
+              </a:spcAft>
+            </a:pPr>
+            <a:r>
+              <a:rPr sz="900">
+                <a:solidFill>
+                  <a:srgbClr val="2D2D2D"/>
+                </a:solidFill>
+                <a:latin typeface="Consolas"/>
+              </a:rPr>
+              <a:t>docker/sdk</a:t>
+            </a:r>
+            <a:r>
+              <a:rPr sz="900">
+                <a:solidFill>
+                  <a:srgbClr val="2D2D2D"/>
+                </a:solidFill>
+                <a:latin typeface="Consolas"/>
+              </a:rPr>
+              <a:t> console cache:empty-all</a:t>
+            </a:r>
+          </a:p>
+          <a:p>
+            <a:pPr>
+              <a:spcBef>
+                <a:spcPts val="0"/>
+              </a:spcBef>
+              <a:spcAft>
+                <a:spcPts val="0"/>
+              </a:spcAft>
+            </a:pPr>
+            <a:r>
+              <a:rPr sz="900">
+                <a:solidFill>
+                  <a:srgbClr val="2D2D2D"/>
+                </a:solidFill>
+                <a:latin typeface="Consolas"/>
+              </a:rPr>
+              <a:t>docker/sdk</a:t>
+            </a:r>
+            <a:r>
+              <a:rPr sz="900">
+                <a:solidFill>
+                  <a:srgbClr val="2D2D2D"/>
+                </a:solidFill>
+                <a:latin typeface="Consolas"/>
+              </a:rPr>
+              <a:t> console propel:model:build</a:t>
             </a:r>
           </a:p>
         </p:txBody>
@@ -30346,7 +30264,7 @@
               </a:defRPr>
             </a:pPr>
             <a:r>
-              <a:t>Form Data Binding with Transfer Objects</a:t>
+              <a:t>Best Practices Applied in This Exercise</a:t>
             </a:r>
           </a:p>
         </p:txBody>
@@ -30417,6 +30335,24 @@
           <a:lstStyle/>
           <a:p>
             <a:pPr>
+              <a:spcBef>
+                <a:spcPts val="1200"/>
+              </a:spcBef>
+              <a:spcAft>
+                <a:spcPts val="600"/>
+              </a:spcAft>
+              <a:defRPr sz="2000" b="1">
+                <a:solidFill>
+                  <a:srgbClr val="1A1A1A"/>
+                </a:solidFill>
+              </a:defRPr>
+            </a:pPr>
+            <a:r>
+              <a:t>SOLID: Single Responsibility for Business Models</a:t>
+            </a:r>
+          </a:p>
+          <a:p>
+            <a:pPr>
               <a:spcAft>
                 <a:spcPts val="800"/>
               </a:spcAft>
@@ -30427,263 +30363,87 @@
               </a:defRPr>
             </a:pPr>
             <a:r>
-              <a:t>Instead of extracting form data from arrays:</a:t>
-            </a:r>
-          </a:p>
-          <a:p>
-            <a:pPr>
-              <a:spcBef>
-                <a:spcPts val="0"/>
-              </a:spcBef>
-              <a:spcAft>
-                <a:spcPts val="0"/>
-              </a:spcAft>
-            </a:pPr>
-            <a:r>
-              <a:rPr sz="900" i="1">
-                <a:solidFill>
-                  <a:srgbClr val="60A0B0"/>
-                </a:solidFill>
-                <a:latin typeface="Consolas"/>
-              </a:rPr>
-              <a:t>// Avoid this</a:t>
-            </a:r>
-          </a:p>
-          <a:p>
-            <a:pPr>
-              <a:spcBef>
-                <a:spcPts val="0"/>
-              </a:spcBef>
-              <a:spcAft>
-                <a:spcPts val="0"/>
-              </a:spcAft>
-            </a:pPr>
-            <a:r>
-              <a:rPr sz="900">
-                <a:solidFill>
-                  <a:srgbClr val="19177C"/>
-                </a:solidFill>
-                <a:latin typeface="Consolas"/>
-              </a:rPr>
-              <a:t>$formData</a:t>
-            </a:r>
-            <a:r>
-              <a:rPr sz="900">
-                <a:solidFill>
-                  <a:srgbClr val="2D2D2D"/>
-                </a:solidFill>
-                <a:latin typeface="Consolas"/>
-              </a:rPr>
-              <a:t> </a:t>
-            </a:r>
-            <a:r>
-              <a:rPr sz="900">
-                <a:solidFill>
-                  <a:srgbClr val="666666"/>
-                </a:solidFill>
-                <a:latin typeface="Consolas"/>
-              </a:rPr>
-              <a:t>=</a:t>
-            </a:r>
-            <a:r>
-              <a:rPr sz="900">
-                <a:solidFill>
-                  <a:srgbClr val="2D2D2D"/>
-                </a:solidFill>
-                <a:latin typeface="Consolas"/>
-              </a:rPr>
-              <a:t> </a:t>
-            </a:r>
-            <a:r>
-              <a:rPr sz="900">
-                <a:solidFill>
-                  <a:srgbClr val="19177C"/>
-                </a:solidFill>
-                <a:latin typeface="Consolas"/>
-              </a:rPr>
-              <a:t>$messageForm</a:t>
-            </a:r>
-            <a:r>
-              <a:rPr sz="900">
-                <a:solidFill>
-                  <a:srgbClr val="2D2D2D"/>
-                </a:solidFill>
-                <a:latin typeface="Consolas"/>
-              </a:rPr>
-              <a:t>-&gt;getData()</a:t>
-            </a:r>
-            <a:r>
-              <a:rPr sz="900">
-                <a:solidFill>
-                  <a:srgbClr val="007020"/>
-                </a:solidFill>
-                <a:latin typeface="Consolas"/>
-              </a:rPr>
-              <a:t>;</a:t>
-            </a:r>
-          </a:p>
-          <a:p>
-            <a:pPr>
-              <a:spcBef>
-                <a:spcPts val="0"/>
-              </a:spcBef>
-              <a:spcAft>
-                <a:spcPts val="0"/>
-              </a:spcAft>
-            </a:pPr>
-            <a:r>
-              <a:rPr sz="900">
-                <a:solidFill>
-                  <a:srgbClr val="19177C"/>
-                </a:solidFill>
-                <a:latin typeface="Consolas"/>
-              </a:rPr>
-              <a:t>$contactRequestTransfer</a:t>
-            </a:r>
-            <a:r>
-              <a:rPr sz="900">
-                <a:solidFill>
-                  <a:srgbClr val="2D2D2D"/>
-                </a:solidFill>
-                <a:latin typeface="Consolas"/>
-              </a:rPr>
-              <a:t> </a:t>
-            </a:r>
-            <a:r>
-              <a:rPr sz="900">
-                <a:solidFill>
-                  <a:srgbClr val="666666"/>
-                </a:solidFill>
-                <a:latin typeface="Consolas"/>
-              </a:rPr>
-              <a:t>=</a:t>
-            </a:r>
-            <a:r>
-              <a:rPr sz="900">
-                <a:solidFill>
-                  <a:srgbClr val="2D2D2D"/>
-                </a:solidFill>
-                <a:latin typeface="Consolas"/>
-              </a:rPr>
-              <a:t> </a:t>
-            </a:r>
-            <a:r>
-              <a:rPr sz="900" b="1">
-                <a:solidFill>
-                  <a:srgbClr val="007020"/>
-                </a:solidFill>
-                <a:latin typeface="Consolas"/>
-              </a:rPr>
-              <a:t>new</a:t>
-            </a:r>
-            <a:r>
-              <a:rPr sz="900">
-                <a:solidFill>
-                  <a:srgbClr val="2D2D2D"/>
-                </a:solidFill>
-                <a:latin typeface="Consolas"/>
-              </a:rPr>
-              <a:t> </a:t>
-            </a:r>
-            <a:r>
-              <a:rPr sz="900">
-                <a:solidFill>
-                  <a:srgbClr val="880000"/>
-                </a:solidFill>
-                <a:latin typeface="Consolas"/>
-              </a:rPr>
-              <a:t>C</a:t>
-            </a:r>
-            <a:r>
-              <a:rPr sz="900">
-                <a:solidFill>
-                  <a:srgbClr val="2D2D2D"/>
-                </a:solidFill>
-                <a:latin typeface="Consolas"/>
-              </a:rPr>
-              <a:t>ontactRequestTransfer()</a:t>
-            </a:r>
-            <a:r>
-              <a:rPr sz="900">
-                <a:solidFill>
-                  <a:srgbClr val="007020"/>
-                </a:solidFill>
-                <a:latin typeface="Consolas"/>
-              </a:rPr>
-              <a:t>;</a:t>
-            </a:r>
-          </a:p>
-          <a:p>
-            <a:pPr>
-              <a:spcBef>
-                <a:spcPts val="0"/>
-              </a:spcBef>
-              <a:spcAft>
-                <a:spcPts val="0"/>
-              </a:spcAft>
-            </a:pPr>
-            <a:r>
-              <a:rPr sz="900">
-                <a:solidFill>
-                  <a:srgbClr val="19177C"/>
-                </a:solidFill>
-                <a:latin typeface="Consolas"/>
-              </a:rPr>
-              <a:t>$contactRequestTransfer</a:t>
-            </a:r>
-            <a:r>
-              <a:rPr sz="900">
-                <a:solidFill>
-                  <a:srgbClr val="2D2D2D"/>
-                </a:solidFill>
-                <a:latin typeface="Consolas"/>
-              </a:rPr>
-              <a:t>-&gt;setMessage(</a:t>
-            </a:r>
-            <a:r>
-              <a:rPr sz="900">
-                <a:solidFill>
-                  <a:srgbClr val="19177C"/>
-                </a:solidFill>
-                <a:latin typeface="Consolas"/>
-              </a:rPr>
-              <a:t>$formData</a:t>
-            </a:r>
-            <a:r>
-              <a:rPr sz="900">
-                <a:solidFill>
-                  <a:srgbClr val="2D2D2D"/>
-                </a:solidFill>
-                <a:latin typeface="Consolas"/>
-              </a:rPr>
-              <a:t>[</a:t>
-            </a:r>
-            <a:r>
-              <a:rPr sz="900">
-                <a:solidFill>
-                  <a:srgbClr val="4070A0"/>
-                </a:solidFill>
-                <a:latin typeface="Consolas"/>
-              </a:rPr>
-              <a:t>'message'</a:t>
-            </a:r>
-            <a:r>
-              <a:rPr sz="900">
-                <a:solidFill>
-                  <a:srgbClr val="2D2D2D"/>
-                </a:solidFill>
-                <a:latin typeface="Consolas"/>
-              </a:rPr>
-              <a:t>])</a:t>
-            </a:r>
-            <a:r>
-              <a:rPr sz="900">
-                <a:solidFill>
-                  <a:srgbClr val="007020"/>
-                </a:solidFill>
-                <a:latin typeface="Consolas"/>
-              </a:rPr>
-              <a:t>;</a:t>
+              <a:t>The business layer separates concerns into dedicated classes:</a:t>
+            </a:r>
+          </a:p>
+          <a:p>
+            <a:pPr>
+              <a:spcAft>
+                <a:spcPts val="100"/>
+              </a:spcAft>
+              <a:defRPr sz="1000">
+                <a:solidFill>
+                  <a:srgbClr val="1A1A1A"/>
+                </a:solidFill>
+                <a:latin typeface="Consolas"/>
+              </a:defRPr>
+            </a:pPr>
+            <a:r>
+              <a:t>Class                  Responsibility                                   </a:t>
+            </a:r>
+          </a:p>
+          <a:p>
+            <a:pPr>
+              <a:spcAft>
+                <a:spcPts val="100"/>
+              </a:spcAft>
+              <a:defRPr sz="1000">
+                <a:solidFill>
+                  <a:srgbClr val="1A1A1A"/>
+                </a:solidFill>
+                <a:latin typeface="Consolas"/>
+              </a:defRPr>
+            </a:pPr>
+            <a:r>
+              <a:t>---------------------  -------------------------------------------------</a:t>
+            </a:r>
+          </a:p>
+          <a:p>
+            <a:pPr>
+              <a:spcAft>
+                <a:spcPts val="100"/>
+              </a:spcAft>
+              <a:defRPr sz="1000">
+                <a:solidFill>
+                  <a:srgbClr val="1A1A1A"/>
+                </a:solidFill>
+                <a:latin typeface="Consolas"/>
+              </a:defRPr>
+            </a:pPr>
+            <a:r>
+              <a:t>ContactRequestReader   Reading/querying messages (uses Repository)      </a:t>
+            </a:r>
+          </a:p>
+          <a:p>
+            <a:pPr>
+              <a:spcAft>
+                <a:spcPts val="100"/>
+              </a:spcAft>
+              <a:defRPr sz="1000">
+                <a:solidFill>
+                  <a:srgbClr val="1A1A1A"/>
+                </a:solidFill>
+                <a:latin typeface="Consolas"/>
+              </a:defRPr>
+            </a:pPr>
+            <a:r>
+              <a:t>ContactRequestWriter   Creating/persisting messages (uses EntityManager)</a:t>
+            </a:r>
+          </a:p>
+          <a:p>
+            <a:pPr>
+              <a:spcAft>
+                <a:spcPts val="100"/>
+              </a:spcAft>
+              <a:defRPr sz="1000">
+                <a:solidFill>
+                  <a:srgbClr val="1A1A1A"/>
+                </a:solidFill>
+                <a:latin typeface="Consolas"/>
+              </a:defRPr>
+            </a:pPr>
+            <a:r>
+              <a:t>ContactRequestDeleter  Deleting messages (uses EntityManager)</a:t>
             </a:r>
           </a:p>
           <a:p>
@@ -30698,281 +30458,7 @@
               </a:defRPr>
             </a:pPr>
             <a:r>
-              <a:t>Bind the form directly to a transfer:</a:t>
-            </a:r>
-          </a:p>
-          <a:p>
-            <a:pPr>
-              <a:spcBef>
-                <a:spcPts val="0"/>
-              </a:spcBef>
-              <a:spcAft>
-                <a:spcPts val="0"/>
-              </a:spcAft>
-            </a:pPr>
-            <a:r>
-              <a:rPr sz="900" i="1">
-                <a:solidFill>
-                  <a:srgbClr val="60A0B0"/>
-                </a:solidFill>
-                <a:latin typeface="Consolas"/>
-              </a:rPr>
-              <a:t>// Preferred</a:t>
-            </a:r>
-          </a:p>
-          <a:p>
-            <a:pPr>
-              <a:spcBef>
-                <a:spcPts val="0"/>
-              </a:spcBef>
-              <a:spcAft>
-                <a:spcPts val="0"/>
-              </a:spcAft>
-            </a:pPr>
-            <a:r>
-              <a:rPr sz="900">
-                <a:solidFill>
-                  <a:srgbClr val="19177C"/>
-                </a:solidFill>
-                <a:latin typeface="Consolas"/>
-              </a:rPr>
-              <a:t>$messageForm</a:t>
-            </a:r>
-            <a:r>
-              <a:rPr sz="900">
-                <a:solidFill>
-                  <a:srgbClr val="2D2D2D"/>
-                </a:solidFill>
-                <a:latin typeface="Consolas"/>
-              </a:rPr>
-              <a:t> </a:t>
-            </a:r>
-            <a:r>
-              <a:rPr sz="900">
-                <a:solidFill>
-                  <a:srgbClr val="666666"/>
-                </a:solidFill>
-                <a:latin typeface="Consolas"/>
-              </a:rPr>
-              <a:t>=</a:t>
-            </a:r>
-            <a:r>
-              <a:rPr sz="900">
-                <a:solidFill>
-                  <a:srgbClr val="2D2D2D"/>
-                </a:solidFill>
-                <a:latin typeface="Consolas"/>
-              </a:rPr>
-              <a:t> </a:t>
-            </a:r>
-            <a:r>
-              <a:rPr sz="900">
-                <a:solidFill>
-                  <a:srgbClr val="19177C"/>
-                </a:solidFill>
-                <a:latin typeface="Consolas"/>
-              </a:rPr>
-              <a:t>$factory</a:t>
-            </a:r>
-            <a:r>
-              <a:rPr sz="900">
-                <a:solidFill>
-                  <a:srgbClr val="2D2D2D"/>
-                </a:solidFill>
-                <a:latin typeface="Consolas"/>
-              </a:rPr>
-              <a:t>-&gt;createContactRequestForm(</a:t>
-            </a:r>
-            <a:r>
-              <a:rPr sz="900" b="1">
-                <a:solidFill>
-                  <a:srgbClr val="007020"/>
-                </a:solidFill>
-                <a:latin typeface="Consolas"/>
-              </a:rPr>
-              <a:t>new</a:t>
-            </a:r>
-            <a:r>
-              <a:rPr sz="900">
-                <a:solidFill>
-                  <a:srgbClr val="2D2D2D"/>
-                </a:solidFill>
-                <a:latin typeface="Consolas"/>
-              </a:rPr>
-              <a:t> </a:t>
-            </a:r>
-            <a:r>
-              <a:rPr sz="900">
-                <a:solidFill>
-                  <a:srgbClr val="880000"/>
-                </a:solidFill>
-                <a:latin typeface="Consolas"/>
-              </a:rPr>
-              <a:t>C</a:t>
-            </a:r>
-            <a:r>
-              <a:rPr sz="900">
-                <a:solidFill>
-                  <a:srgbClr val="2D2D2D"/>
-                </a:solidFill>
-                <a:latin typeface="Consolas"/>
-              </a:rPr>
-              <a:t>ontactRequestTransfer())</a:t>
-            </a:r>
-            <a:r>
-              <a:rPr sz="900">
-                <a:solidFill>
-                  <a:srgbClr val="007020"/>
-                </a:solidFill>
-                <a:latin typeface="Consolas"/>
-              </a:rPr>
-              <a:t>;</a:t>
-            </a:r>
-          </a:p>
-          <a:p>
-            <a:pPr>
-              <a:spcBef>
-                <a:spcPts val="0"/>
-              </a:spcBef>
-              <a:spcAft>
-                <a:spcPts val="0"/>
-              </a:spcAft>
-            </a:pPr>
-            <a:r>
-              <a:rPr sz="900">
-                <a:solidFill>
-                  <a:srgbClr val="19177C"/>
-                </a:solidFill>
-                <a:latin typeface="Consolas"/>
-              </a:rPr>
-              <a:t>$messageForm</a:t>
-            </a:r>
-            <a:r>
-              <a:rPr sz="900">
-                <a:solidFill>
-                  <a:srgbClr val="2D2D2D"/>
-                </a:solidFill>
-                <a:latin typeface="Consolas"/>
-              </a:rPr>
-              <a:t>-&gt;handleRequest(</a:t>
-            </a:r>
-            <a:r>
-              <a:rPr sz="900">
-                <a:solidFill>
-                  <a:srgbClr val="19177C"/>
-                </a:solidFill>
-                <a:latin typeface="Consolas"/>
-              </a:rPr>
-              <a:t>$request</a:t>
-            </a:r>
-            <a:r>
-              <a:rPr sz="900">
-                <a:solidFill>
-                  <a:srgbClr val="2D2D2D"/>
-                </a:solidFill>
-                <a:latin typeface="Consolas"/>
-              </a:rPr>
-              <a:t>)</a:t>
-            </a:r>
-            <a:r>
-              <a:rPr sz="900">
-                <a:solidFill>
-                  <a:srgbClr val="007020"/>
-                </a:solidFill>
-                <a:latin typeface="Consolas"/>
-              </a:rPr>
-              <a:t>;</a:t>
-            </a:r>
-          </a:p>
-          <a:p>
-            <a:pPr>
-              <a:spcBef>
-                <a:spcPts val="0"/>
-              </a:spcBef>
-              <a:spcAft>
-                <a:spcPts val="0"/>
-              </a:spcAft>
-            </a:pPr>
-            <a:r>
-              <a:rPr sz="900">
-                <a:solidFill>
-                  <a:srgbClr val="19177C"/>
-                </a:solidFill>
-                <a:latin typeface="Consolas"/>
-              </a:rPr>
-              <a:t>$contactRequestTransfer</a:t>
-            </a:r>
-            <a:r>
-              <a:rPr sz="900">
-                <a:solidFill>
-                  <a:srgbClr val="2D2D2D"/>
-                </a:solidFill>
-                <a:latin typeface="Consolas"/>
-              </a:rPr>
-              <a:t> </a:t>
-            </a:r>
-            <a:r>
-              <a:rPr sz="900">
-                <a:solidFill>
-                  <a:srgbClr val="666666"/>
-                </a:solidFill>
-                <a:latin typeface="Consolas"/>
-              </a:rPr>
-              <a:t>=</a:t>
-            </a:r>
-            <a:r>
-              <a:rPr sz="900">
-                <a:solidFill>
-                  <a:srgbClr val="2D2D2D"/>
-                </a:solidFill>
-                <a:latin typeface="Consolas"/>
-              </a:rPr>
-              <a:t> </a:t>
-            </a:r>
-            <a:r>
-              <a:rPr sz="900">
-                <a:solidFill>
-                  <a:srgbClr val="19177C"/>
-                </a:solidFill>
-                <a:latin typeface="Consolas"/>
-              </a:rPr>
-              <a:t>$messageForm</a:t>
-            </a:r>
-            <a:r>
-              <a:rPr sz="900">
-                <a:solidFill>
-                  <a:srgbClr val="2D2D2D"/>
-                </a:solidFill>
-                <a:latin typeface="Consolas"/>
-              </a:rPr>
-              <a:t>-&gt;getData()</a:t>
-            </a:r>
-            <a:r>
-              <a:rPr sz="900">
-                <a:solidFill>
-                  <a:srgbClr val="007020"/>
-                </a:solidFill>
-                <a:latin typeface="Consolas"/>
-              </a:rPr>
-              <a:t>;</a:t>
-            </a:r>
-            <a:r>
-              <a:rPr sz="900">
-                <a:solidFill>
-                  <a:srgbClr val="2D2D2D"/>
-                </a:solidFill>
-                <a:latin typeface="Consolas"/>
-              </a:rPr>
-              <a:t> </a:t>
-            </a:r>
-            <a:r>
-              <a:rPr sz="900" i="1">
-                <a:solidFill>
-                  <a:srgbClr val="60A0B0"/>
-                </a:solidFill>
-                <a:latin typeface="Consolas"/>
-              </a:rPr>
-              <a:t>// Already a ContactRequestTransfer</a:t>
+              <a:t>Each class has one reason to change . The Writer does not know how to delete. The Deleter does not know how to create. The Facade orchestrates all three through the BusinessFactory.</a:t>
             </a:r>
           </a:p>
         </p:txBody>
@@ -31025,7 +30511,7 @@
               </a:defRPr>
             </a:pPr>
             <a:r>
-              <a:t>Safe ID Handling with castId()</a:t>
+              <a:t>Form Data Binding with Transfer Objects</a:t>
             </a:r>
           </a:p>
         </p:txBody>
@@ -31106,7 +30592,26 @@
               </a:defRPr>
             </a:pPr>
             <a:r>
-              <a:t>Always validate IDs from user input before passing them to the persistence layer:</a:t>
+              <a:t>Instead of extracting form data from arrays:</a:t>
+            </a:r>
+          </a:p>
+          <a:p>
+            <a:pPr>
+              <a:spcBef>
+                <a:spcPts val="0"/>
+              </a:spcBef>
+              <a:spcAft>
+                <a:spcPts val="0"/>
+              </a:spcAft>
+            </a:pPr>
+            <a:r>
+              <a:rPr sz="900" i="1">
+                <a:solidFill>
+                  <a:srgbClr val="60A0B0"/>
+                </a:solidFill>
+                <a:latin typeface="Consolas"/>
+              </a:rPr>
+              <a:t>// Avoid this</a:t>
             </a:r>
           </a:p>
           <a:p>
@@ -31125,7 +30630,7 @@
                 </a:solidFill>
                 <a:latin typeface="Consolas"/>
               </a:rPr>
-              <a:t>$idContactRequest</a:t>
+              <a:t>$formData</a:t>
             </a:r>
             <a:r>
               <a:rPr sz="900">
@@ -31161,17 +30666,36 @@
                 </a:solidFill>
                 <a:latin typeface="Consolas"/>
               </a:rPr>
-              <a:t>$this</a:t>
-            </a:r>
-            <a:r>
-              <a:rPr sz="900">
-                <a:solidFill>
-                  <a:srgbClr val="2D2D2D"/>
-                </a:solidFill>
-                <a:latin typeface="Consolas"/>
-              </a:rPr>
-              <a:t>-&gt;castId(</a:t>
-            </a:r>
+              <a:t>$messageForm</a:t>
+            </a:r>
+            <a:r>
+              <a:rPr sz="900">
+                <a:solidFill>
+                  <a:srgbClr val="2D2D2D"/>
+                </a:solidFill>
+                <a:latin typeface="Consolas"/>
+              </a:rPr>
+              <a:t>-&gt;getData()</a:t>
+            </a:r>
+            <a:r>
+              <a:rPr sz="900">
+                <a:solidFill>
+                  <a:srgbClr val="007020"/>
+                </a:solidFill>
+                <a:latin typeface="Consolas"/>
+              </a:rPr>
+              <a:t>;</a:t>
+            </a:r>
+          </a:p>
+          <a:p>
+            <a:pPr>
+              <a:spcBef>
+                <a:spcPts val="0"/>
+              </a:spcBef>
+              <a:spcAft>
+                <a:spcPts val="0"/>
+              </a:spcAft>
+            </a:pPr>
             <a:r>
               <a:rPr sz="900">
                 <a:solidFill>
@@ -31179,6 +30703,331 @@
                 </a:solidFill>
                 <a:latin typeface="Consolas"/>
               </a:rPr>
+              <a:t>$contactRequestTransfer</a:t>
+            </a:r>
+            <a:r>
+              <a:rPr sz="900">
+                <a:solidFill>
+                  <a:srgbClr val="2D2D2D"/>
+                </a:solidFill>
+                <a:latin typeface="Consolas"/>
+              </a:rPr>
+              <a:t> </a:t>
+            </a:r>
+            <a:r>
+              <a:rPr sz="900">
+                <a:solidFill>
+                  <a:srgbClr val="666666"/>
+                </a:solidFill>
+                <a:latin typeface="Consolas"/>
+              </a:rPr>
+              <a:t>=</a:t>
+            </a:r>
+            <a:r>
+              <a:rPr sz="900">
+                <a:solidFill>
+                  <a:srgbClr val="2D2D2D"/>
+                </a:solidFill>
+                <a:latin typeface="Consolas"/>
+              </a:rPr>
+              <a:t> </a:t>
+            </a:r>
+            <a:r>
+              <a:rPr sz="900" b="1">
+                <a:solidFill>
+                  <a:srgbClr val="007020"/>
+                </a:solidFill>
+                <a:latin typeface="Consolas"/>
+              </a:rPr>
+              <a:t>new</a:t>
+            </a:r>
+            <a:r>
+              <a:rPr sz="900">
+                <a:solidFill>
+                  <a:srgbClr val="2D2D2D"/>
+                </a:solidFill>
+                <a:latin typeface="Consolas"/>
+              </a:rPr>
+              <a:t> </a:t>
+            </a:r>
+            <a:r>
+              <a:rPr sz="900">
+                <a:solidFill>
+                  <a:srgbClr val="880000"/>
+                </a:solidFill>
+                <a:latin typeface="Consolas"/>
+              </a:rPr>
+              <a:t>C</a:t>
+            </a:r>
+            <a:r>
+              <a:rPr sz="900">
+                <a:solidFill>
+                  <a:srgbClr val="2D2D2D"/>
+                </a:solidFill>
+                <a:latin typeface="Consolas"/>
+              </a:rPr>
+              <a:t>ontactRequestTransfer()</a:t>
+            </a:r>
+            <a:r>
+              <a:rPr sz="900">
+                <a:solidFill>
+                  <a:srgbClr val="007020"/>
+                </a:solidFill>
+                <a:latin typeface="Consolas"/>
+              </a:rPr>
+              <a:t>;</a:t>
+            </a:r>
+          </a:p>
+          <a:p>
+            <a:pPr>
+              <a:spcBef>
+                <a:spcPts val="0"/>
+              </a:spcBef>
+              <a:spcAft>
+                <a:spcPts val="0"/>
+              </a:spcAft>
+            </a:pPr>
+            <a:r>
+              <a:rPr sz="900">
+                <a:solidFill>
+                  <a:srgbClr val="19177C"/>
+                </a:solidFill>
+                <a:latin typeface="Consolas"/>
+              </a:rPr>
+              <a:t>$contactRequestTransfer</a:t>
+            </a:r>
+            <a:r>
+              <a:rPr sz="900">
+                <a:solidFill>
+                  <a:srgbClr val="2D2D2D"/>
+                </a:solidFill>
+                <a:latin typeface="Consolas"/>
+              </a:rPr>
+              <a:t>-&gt;setMessage(</a:t>
+            </a:r>
+            <a:r>
+              <a:rPr sz="900">
+                <a:solidFill>
+                  <a:srgbClr val="19177C"/>
+                </a:solidFill>
+                <a:latin typeface="Consolas"/>
+              </a:rPr>
+              <a:t>$formData</a:t>
+            </a:r>
+            <a:r>
+              <a:rPr sz="900">
+                <a:solidFill>
+                  <a:srgbClr val="2D2D2D"/>
+                </a:solidFill>
+                <a:latin typeface="Consolas"/>
+              </a:rPr>
+              <a:t>[</a:t>
+            </a:r>
+            <a:r>
+              <a:rPr sz="900">
+                <a:solidFill>
+                  <a:srgbClr val="4070A0"/>
+                </a:solidFill>
+                <a:latin typeface="Consolas"/>
+              </a:rPr>
+              <a:t>'message'</a:t>
+            </a:r>
+            <a:r>
+              <a:rPr sz="900">
+                <a:solidFill>
+                  <a:srgbClr val="2D2D2D"/>
+                </a:solidFill>
+                <a:latin typeface="Consolas"/>
+              </a:rPr>
+              <a:t>])</a:t>
+            </a:r>
+            <a:r>
+              <a:rPr sz="900">
+                <a:solidFill>
+                  <a:srgbClr val="007020"/>
+                </a:solidFill>
+                <a:latin typeface="Consolas"/>
+              </a:rPr>
+              <a:t>;</a:t>
+            </a:r>
+          </a:p>
+          <a:p>
+            <a:pPr>
+              <a:spcAft>
+                <a:spcPts val="800"/>
+              </a:spcAft>
+              <a:defRPr sz="1600">
+                <a:solidFill>
+                  <a:srgbClr val="1A1A1A"/>
+                </a:solidFill>
+              </a:defRPr>
+            </a:pPr>
+            <a:r>
+              <a:t>Bind the form directly to a transfer:</a:t>
+            </a:r>
+          </a:p>
+          <a:p>
+            <a:pPr>
+              <a:spcBef>
+                <a:spcPts val="0"/>
+              </a:spcBef>
+              <a:spcAft>
+                <a:spcPts val="0"/>
+              </a:spcAft>
+            </a:pPr>
+            <a:r>
+              <a:rPr sz="900" i="1">
+                <a:solidFill>
+                  <a:srgbClr val="60A0B0"/>
+                </a:solidFill>
+                <a:latin typeface="Consolas"/>
+              </a:rPr>
+              <a:t>// Preferred</a:t>
+            </a:r>
+          </a:p>
+          <a:p>
+            <a:pPr>
+              <a:spcBef>
+                <a:spcPts val="0"/>
+              </a:spcBef>
+              <a:spcAft>
+                <a:spcPts val="0"/>
+              </a:spcAft>
+            </a:pPr>
+            <a:r>
+              <a:rPr sz="900">
+                <a:solidFill>
+                  <a:srgbClr val="19177C"/>
+                </a:solidFill>
+                <a:latin typeface="Consolas"/>
+              </a:rPr>
+              <a:t>$messageForm</a:t>
+            </a:r>
+            <a:r>
+              <a:rPr sz="900">
+                <a:solidFill>
+                  <a:srgbClr val="2D2D2D"/>
+                </a:solidFill>
+                <a:latin typeface="Consolas"/>
+              </a:rPr>
+              <a:t> </a:t>
+            </a:r>
+            <a:r>
+              <a:rPr sz="900">
+                <a:solidFill>
+                  <a:srgbClr val="666666"/>
+                </a:solidFill>
+                <a:latin typeface="Consolas"/>
+              </a:rPr>
+              <a:t>=</a:t>
+            </a:r>
+            <a:r>
+              <a:rPr sz="900">
+                <a:solidFill>
+                  <a:srgbClr val="2D2D2D"/>
+                </a:solidFill>
+                <a:latin typeface="Consolas"/>
+              </a:rPr>
+              <a:t> </a:t>
+            </a:r>
+            <a:r>
+              <a:rPr sz="900">
+                <a:solidFill>
+                  <a:srgbClr val="19177C"/>
+                </a:solidFill>
+                <a:latin typeface="Consolas"/>
+              </a:rPr>
+              <a:t>$factory</a:t>
+            </a:r>
+            <a:r>
+              <a:rPr sz="900">
+                <a:solidFill>
+                  <a:srgbClr val="2D2D2D"/>
+                </a:solidFill>
+                <a:latin typeface="Consolas"/>
+              </a:rPr>
+              <a:t>-&gt;createContactRequestForm(</a:t>
+            </a:r>
+            <a:r>
+              <a:rPr sz="900" b="1">
+                <a:solidFill>
+                  <a:srgbClr val="007020"/>
+                </a:solidFill>
+                <a:latin typeface="Consolas"/>
+              </a:rPr>
+              <a:t>new</a:t>
+            </a:r>
+            <a:r>
+              <a:rPr sz="900">
+                <a:solidFill>
+                  <a:srgbClr val="2D2D2D"/>
+                </a:solidFill>
+                <a:latin typeface="Consolas"/>
+              </a:rPr>
+              <a:t> </a:t>
+            </a:r>
+            <a:r>
+              <a:rPr sz="900">
+                <a:solidFill>
+                  <a:srgbClr val="880000"/>
+                </a:solidFill>
+                <a:latin typeface="Consolas"/>
+              </a:rPr>
+              <a:t>C</a:t>
+            </a:r>
+            <a:r>
+              <a:rPr sz="900">
+                <a:solidFill>
+                  <a:srgbClr val="2D2D2D"/>
+                </a:solidFill>
+                <a:latin typeface="Consolas"/>
+              </a:rPr>
+              <a:t>ontactRequestTransfer())</a:t>
+            </a:r>
+            <a:r>
+              <a:rPr sz="900">
+                <a:solidFill>
+                  <a:srgbClr val="007020"/>
+                </a:solidFill>
+                <a:latin typeface="Consolas"/>
+              </a:rPr>
+              <a:t>;</a:t>
+            </a:r>
+          </a:p>
+          <a:p>
+            <a:pPr>
+              <a:spcBef>
+                <a:spcPts val="0"/>
+              </a:spcBef>
+              <a:spcAft>
+                <a:spcPts val="0"/>
+              </a:spcAft>
+            </a:pPr>
+            <a:r>
+              <a:rPr sz="900">
+                <a:solidFill>
+                  <a:srgbClr val="19177C"/>
+                </a:solidFill>
+                <a:latin typeface="Consolas"/>
+              </a:rPr>
+              <a:t>$messageForm</a:t>
+            </a:r>
+            <a:r>
+              <a:rPr sz="900">
+                <a:solidFill>
+                  <a:srgbClr val="2D2D2D"/>
+                </a:solidFill>
+                <a:latin typeface="Consolas"/>
+              </a:rPr>
+              <a:t>-&gt;handleRequest(</a:t>
+            </a:r>
+            <a:r>
+              <a:rPr sz="900">
+                <a:solidFill>
+                  <a:srgbClr val="19177C"/>
+                </a:solidFill>
+                <a:latin typeface="Consolas"/>
+              </a:rPr>
               <a:t>$request</a:t>
             </a:r>
             <a:r>
@@ -31188,25 +31037,7 @@
                 </a:solidFill>
                 <a:latin typeface="Consolas"/>
               </a:rPr>
-              <a:t>-&gt;request-&gt;get(</a:t>
-            </a:r>
-            <a:r>
-              <a:rPr sz="900">
-                <a:solidFill>
-                  <a:srgbClr val="4070A0"/>
-                </a:solidFill>
-                <a:latin typeface="Consolas"/>
-              </a:rPr>
-              <a:t>'idContactRequest'</a:t>
-            </a:r>
-            <a:r>
-              <a:rPr sz="900">
-                <a:solidFill>
-                  <a:srgbClr val="2D2D2D"/>
-                </a:solidFill>
-                <a:latin typeface="Consolas"/>
-              </a:rPr>
-              <a:t>))</a:t>
+              <a:t>)</a:t>
             </a:r>
             <a:r>
               <a:rPr sz="900">
@@ -31228,13 +31059,85 @@
               </a:spcAft>
             </a:pPr>
             <a:r>
+              <a:rPr sz="900">
+                <a:solidFill>
+                  <a:srgbClr val="19177C"/>
+                </a:solidFill>
+                <a:latin typeface="Consolas"/>
+              </a:rPr>
+              <a:t>$contactRequestTransfer</a:t>
+            </a:r>
+            <a:r>
+              <a:rPr sz="900">
+                <a:solidFill>
+                  <a:srgbClr val="2D2D2D"/>
+                </a:solidFill>
+                <a:latin typeface="Consolas"/>
+              </a:rPr>
+              <a:t> </a:t>
+            </a:r>
+            <a:r>
+              <a:rPr sz="900">
+                <a:solidFill>
+                  <a:srgbClr val="666666"/>
+                </a:solidFill>
+                <a:latin typeface="Consolas"/>
+              </a:rPr>
+              <a:t>=</a:t>
+            </a:r>
+            <a:r>
+              <a:rPr sz="900">
+                <a:solidFill>
+                  <a:srgbClr val="2D2D2D"/>
+                </a:solidFill>
+                <a:latin typeface="Consolas"/>
+              </a:rPr>
+              <a:t> </a:t>
+            </a:r>
+            <a:r>
+              <a:rPr sz="900">
+                <a:solidFill>
+                  <a:srgbClr val="19177C"/>
+                </a:solidFill>
+                <a:latin typeface="Consolas"/>
+              </a:rPr>
+              <a:t>$messageForm</a:t>
+            </a:r>
+            <a:r>
+              <a:rPr sz="900">
+                <a:solidFill>
+                  <a:srgbClr val="2D2D2D"/>
+                </a:solidFill>
+                <a:latin typeface="Consolas"/>
+              </a:rPr>
+              <a:t>-&gt;getData()</a:t>
+            </a:r>
+            <a:r>
+              <a:rPr sz="900">
+                <a:solidFill>
+                  <a:srgbClr val="007020"/>
+                </a:solidFill>
+                <a:latin typeface="Consolas"/>
+              </a:rPr>
+              <a:t>;</a:t>
+            </a:r>
+            <a:r>
+              <a:rPr sz="900">
+                <a:solidFill>
+                  <a:srgbClr val="2D2D2D"/>
+                </a:solidFill>
+                <a:latin typeface="Consolas"/>
+              </a:rPr>
+              <a:t> </a:t>
+            </a:r>
+            <a:r>
               <a:rPr sz="900" i="1">
                 <a:solidFill>
                   <a:srgbClr val="60A0B0"/>
                 </a:solidFill>
                 <a:latin typeface="Consolas"/>
               </a:rPr>
-              <a:t>// Throws InvalidArgumentException if not numeric or zero</a:t>
+              <a:t>// Already a ContactRequestTransfer</a:t>
             </a:r>
           </a:p>
         </p:txBody>
@@ -31747,7 +31650,7 @@
               </a:defRPr>
             </a:pPr>
             <a:r>
-              <a:t>Testing</a:t>
+              <a:t>Safe ID Handling with castId()</a:t>
             </a:r>
           </a:p>
         </p:txBody>
@@ -31819,76 +31722,144 @@
           <a:p>
             <a:pPr>
               <a:spcAft>
-                <a:spcPts val="400"/>
-              </a:spcAft>
-              <a:defRPr sz="1500">
+                <a:spcPts val="800"/>
+              </a:spcAft>
+              <a:defRPr sz="1600">
                 <a:solidFill>
                   <a:srgbClr val="1A1A1A"/>
                 </a:solidFill>
               </a:defRPr>
             </a:pPr>
             <a:r>
-              <a:t>• Log in to Yves: http://yves.eu.spryker.local/en/login (use sonia@spryker.com / change123 )</a:t>
-            </a:r>
-          </a:p>
-          <a:p>
-            <a:pPr>
-              <a:spcAft>
-                <a:spcPts val="400"/>
-              </a:spcAft>
-              <a:defRPr sz="1500">
-                <a:solidFill>
-                  <a:srgbClr val="1A1A1A"/>
-                </a:solidFill>
-              </a:defRPr>
-            </a:pPr>
-            <a:r>
-              <a:t>• Visit: http://yves.eu.spryker.local/en/customer/contact-requests</a:t>
-            </a:r>
-          </a:p>
-          <a:p>
-            <a:pPr>
-              <a:spcAft>
-                <a:spcPts val="400"/>
-              </a:spcAft>
-              <a:defRPr sz="1500">
-                <a:solidFill>
-                  <a:srgbClr val="1A1A1A"/>
-                </a:solidFill>
-              </a:defRPr>
-            </a:pPr>
-            <a:r>
-              <a:t>• You should see a message list (empty initially) and a form to add messages</a:t>
-            </a:r>
-          </a:p>
-          <a:p>
-            <a:pPr>
-              <a:spcAft>
-                <a:spcPts val="400"/>
-              </a:spcAft>
-              <a:defRPr sz="1500">
-                <a:solidFill>
-                  <a:srgbClr val="1A1A1A"/>
-                </a:solidFill>
-              </a:defRPr>
-            </a:pPr>
-            <a:r>
-              <a:t>• Add a message and verify it appears in the list with a created timestamp</a:t>
-            </a:r>
-          </a:p>
-          <a:p>
-            <a:pPr>
-              <a:spcAft>
-                <a:spcPts val="400"/>
-              </a:spcAft>
-              <a:defRPr sz="1500">
-                <a:solidFill>
-                  <a:srgbClr val="1A1A1A"/>
-                </a:solidFill>
-              </a:defRPr>
-            </a:pPr>
-            <a:r>
-              <a:t>• Click “Delete” on a message and verify it disappears</a:t>
+              <a:t>Always validate IDs from user input before passing them to the persistence layer:</a:t>
+            </a:r>
+          </a:p>
+          <a:p>
+            <a:pPr>
+              <a:spcBef>
+                <a:spcPts val="0"/>
+              </a:spcBef>
+              <a:spcAft>
+                <a:spcPts val="0"/>
+              </a:spcAft>
+            </a:pPr>
+            <a:r>
+              <a:rPr sz="900">
+                <a:solidFill>
+                  <a:srgbClr val="19177C"/>
+                </a:solidFill>
+                <a:latin typeface="Consolas"/>
+              </a:rPr>
+              <a:t>$idContactRequest</a:t>
+            </a:r>
+            <a:r>
+              <a:rPr sz="900">
+                <a:solidFill>
+                  <a:srgbClr val="2D2D2D"/>
+                </a:solidFill>
+                <a:latin typeface="Consolas"/>
+              </a:rPr>
+              <a:t> </a:t>
+            </a:r>
+            <a:r>
+              <a:rPr sz="900">
+                <a:solidFill>
+                  <a:srgbClr val="666666"/>
+                </a:solidFill>
+                <a:latin typeface="Consolas"/>
+              </a:rPr>
+              <a:t>=</a:t>
+            </a:r>
+            <a:r>
+              <a:rPr sz="900">
+                <a:solidFill>
+                  <a:srgbClr val="2D2D2D"/>
+                </a:solidFill>
+                <a:latin typeface="Consolas"/>
+              </a:rPr>
+              <a:t> </a:t>
+            </a:r>
+            <a:r>
+              <a:rPr sz="900">
+                <a:solidFill>
+                  <a:srgbClr val="19177C"/>
+                </a:solidFill>
+                <a:latin typeface="Consolas"/>
+              </a:rPr>
+              <a:t>$this</a:t>
+            </a:r>
+            <a:r>
+              <a:rPr sz="900">
+                <a:solidFill>
+                  <a:srgbClr val="2D2D2D"/>
+                </a:solidFill>
+                <a:latin typeface="Consolas"/>
+              </a:rPr>
+              <a:t>-&gt;castId(</a:t>
+            </a:r>
+            <a:r>
+              <a:rPr sz="900">
+                <a:solidFill>
+                  <a:srgbClr val="19177C"/>
+                </a:solidFill>
+                <a:latin typeface="Consolas"/>
+              </a:rPr>
+              <a:t>$request</a:t>
+            </a:r>
+            <a:r>
+              <a:rPr sz="900">
+                <a:solidFill>
+                  <a:srgbClr val="2D2D2D"/>
+                </a:solidFill>
+                <a:latin typeface="Consolas"/>
+              </a:rPr>
+              <a:t>-&gt;request-&gt;get(</a:t>
+            </a:r>
+            <a:r>
+              <a:rPr sz="900">
+                <a:solidFill>
+                  <a:srgbClr val="4070A0"/>
+                </a:solidFill>
+                <a:latin typeface="Consolas"/>
+              </a:rPr>
+              <a:t>'idContactRequest'</a:t>
+            </a:r>
+            <a:r>
+              <a:rPr sz="900">
+                <a:solidFill>
+                  <a:srgbClr val="2D2D2D"/>
+                </a:solidFill>
+                <a:latin typeface="Consolas"/>
+              </a:rPr>
+              <a:t>))</a:t>
+            </a:r>
+            <a:r>
+              <a:rPr sz="900">
+                <a:solidFill>
+                  <a:srgbClr val="007020"/>
+                </a:solidFill>
+                <a:latin typeface="Consolas"/>
+              </a:rPr>
+              <a:t>;</a:t>
+            </a:r>
+          </a:p>
+          <a:p>
+            <a:pPr>
+              <a:spcBef>
+                <a:spcPts val="0"/>
+              </a:spcBef>
+              <a:spcAft>
+                <a:spcPts val="0"/>
+              </a:spcAft>
+            </a:pPr>
+            <a:r>
+              <a:rPr sz="900" i="1">
+                <a:solidFill>
+                  <a:srgbClr val="60A0B0"/>
+                </a:solidFill>
+                <a:latin typeface="Consolas"/>
+              </a:rPr>
+              <a:t>// Throws InvalidArgumentException if not numeric or zero</a:t>
             </a:r>
           </a:p>
         </p:txBody>
@@ -31941,7 +31912,7 @@
               </a:defRPr>
             </a:pPr>
             <a:r>
-              <a:t>Verify Your Work</a:t>
+              <a:t>Testing</a:t>
             </a:r>
           </a:p>
         </p:txBody>
@@ -32013,138 +31984,76 @@
           <a:p>
             <a:pPr>
               <a:spcAft>
-                <a:spcPts val="800"/>
-              </a:spcAft>
-              <a:defRPr sz="1600">
+                <a:spcPts val="400"/>
+              </a:spcAft>
+              <a:defRPr sz="1500">
                 <a:solidFill>
                   <a:srgbClr val="1A1A1A"/>
                 </a:solidFill>
               </a:defRPr>
             </a:pPr>
             <a:r>
-              <a:t>Run the automated tests for this exercise:</a:t>
-            </a:r>
-          </a:p>
-          <a:p>
-            <a:pPr>
-              <a:spcBef>
-                <a:spcPts val="0"/>
-              </a:spcBef>
-              <a:spcAft>
-                <a:spcPts val="0"/>
-              </a:spcAft>
-            </a:pPr>
-            <a:r>
-              <a:rPr sz="900">
-                <a:solidFill>
-                  <a:srgbClr val="2D2D2D"/>
-                </a:solidFill>
-                <a:latin typeface="Consolas"/>
-              </a:rPr>
-              <a:t>docker/sdk</a:t>
-            </a:r>
-            <a:r>
-              <a:rPr sz="900">
-                <a:solidFill>
-                  <a:srgbClr val="2D2D2D"/>
-                </a:solidFill>
-                <a:latin typeface="Consolas"/>
-              </a:rPr>
-              <a:t> cli vendor/bin/codecept run </a:t>
-            </a:r>
-            <a:r>
-              <a:rPr sz="900">
-                <a:solidFill>
-                  <a:srgbClr val="2D2D2D"/>
-                </a:solidFill>
-                <a:latin typeface="Consolas"/>
-              </a:rPr>
-              <a:t>-c</a:t>
-            </a:r>
-            <a:r>
-              <a:rPr sz="900">
-                <a:solidFill>
-                  <a:srgbClr val="2D2D2D"/>
-                </a:solidFill>
-                <a:latin typeface="Consolas"/>
-              </a:rPr>
-              <a:t> tests/SprykerAcademyTest/Zed/ContactRequest/ Exercise7</a:t>
-            </a:r>
-          </a:p>
-          <a:p>
-            <a:pPr>
-              <a:spcAft>
-                <a:spcPts val="800"/>
-              </a:spcAft>
-              <a:defRPr sz="1600">
+              <a:t>• Log in to Yves: http://yves.eu.spryker.local/en/login (use sonia@spryker.com / change123 )</a:t>
+            </a:r>
+          </a:p>
+          <a:p>
+            <a:pPr>
+              <a:spcAft>
+                <a:spcPts val="400"/>
+              </a:spcAft>
+              <a:defRPr sz="1500">
                 <a:solidFill>
                   <a:srgbClr val="1A1A1A"/>
                 </a:solidFill>
               </a:defRPr>
             </a:pPr>
             <a:r>
-              <a:t>The test suite covers: - Schema XML: fk_customer column, foreign key, timestampable behavior - Transfer XML: fkCustomer , createdAt properties, ContactRequestCollection transfer ( strict="true" , singular="contactRequest" ) - Structural: All classes and methods exist across the full stack - Mock-based: Stub calls the correct gateway paths for create, get, and delete - Unit: ContactRequestDeleter delegates to EntityManager correctly - SOLID: ContactRequestWriter does NOT have a delete() method</a:t>
-            </a:r>
-          </a:p>
-          <a:p>
-            <a:pPr>
-              <a:spcAft>
-                <a:spcPts val="800"/>
-              </a:spcAft>
-              <a:defRPr sz="1600">
+              <a:t>• Visit: http://yves.eu.spryker.local/en/customer/contact-requests</a:t>
+            </a:r>
+          </a:p>
+          <a:p>
+            <a:pPr>
+              <a:spcAft>
+                <a:spcPts val="400"/>
+              </a:spcAft>
+              <a:defRPr sz="1500">
                 <a:solidFill>
                   <a:srgbClr val="1A1A1A"/>
                 </a:solidFill>
               </a:defRPr>
             </a:pPr>
             <a:r>
-              <a:t>Or run all exercise tests at once:</a:t>
-            </a:r>
-          </a:p>
-          <a:p>
-            <a:pPr>
-              <a:spcBef>
-                <a:spcPts val="0"/>
-              </a:spcBef>
-              <a:spcAft>
-                <a:spcPts val="0"/>
-              </a:spcAft>
-            </a:pPr>
-            <a:r>
-              <a:rPr sz="900">
-                <a:solidFill>
-                  <a:srgbClr val="2D2D2D"/>
-                </a:solidFill>
-                <a:latin typeface="Consolas"/>
-              </a:rPr>
-              <a:t>docker/sdk</a:t>
-            </a:r>
-            <a:r>
-              <a:rPr sz="900">
-                <a:solidFill>
-                  <a:srgbClr val="2D2D2D"/>
-                </a:solidFill>
-                <a:latin typeface="Consolas"/>
-              </a:rPr>
-              <a:t> cli vendor/bin/codecept run </a:t>
-            </a:r>
-            <a:r>
-              <a:rPr sz="900">
-                <a:solidFill>
-                  <a:srgbClr val="2D2D2D"/>
-                </a:solidFill>
-                <a:latin typeface="Consolas"/>
-              </a:rPr>
-              <a:t>-c</a:t>
-            </a:r>
-            <a:r>
-              <a:rPr sz="900">
-                <a:solidFill>
-                  <a:srgbClr val="2D2D2D"/>
-                </a:solidFill>
-                <a:latin typeface="Consolas"/>
-              </a:rPr>
-              <a:t> tests/SprykerAcademyTest/Zed/ContactRequest/</a:t>
+              <a:t>• You should see a message list (empty initially) and a form to add messages</a:t>
+            </a:r>
+          </a:p>
+          <a:p>
+            <a:pPr>
+              <a:spcAft>
+                <a:spcPts val="400"/>
+              </a:spcAft>
+              <a:defRPr sz="1500">
+                <a:solidFill>
+                  <a:srgbClr val="1A1A1A"/>
+                </a:solidFill>
+              </a:defRPr>
+            </a:pPr>
+            <a:r>
+              <a:t>• Add a message and verify it appears in the list with a created timestamp</a:t>
+            </a:r>
+          </a:p>
+          <a:p>
+            <a:pPr>
+              <a:spcAft>
+                <a:spcPts val="400"/>
+              </a:spcAft>
+              <a:defRPr sz="1500">
+                <a:solidFill>
+                  <a:srgbClr val="1A1A1A"/>
+                </a:solidFill>
+              </a:defRPr>
+            </a:pPr>
+            <a:r>
+              <a:t>• Click “Delete” on a message and verify it disappears</a:t>
             </a:r>
           </a:p>
         </p:txBody>
@@ -32197,7 +32106,7 @@
               </a:defRPr>
             </a:pPr>
             <a:r>
-              <a:t>Solution</a:t>
+              <a:t>Verify Your Work</a:t>
             </a:r>
           </a:p>
         </p:txBody>
@@ -32268,30 +32177,139 @@
           <a:lstStyle/>
           <a:p>
             <a:pPr>
-              <a:spcBef>
-                <a:spcPts val="0"/>
-              </a:spcBef>
-              <a:spcAft>
-                <a:spcPts val="0"/>
-              </a:spcAft>
-            </a:pPr>
-            <a:r>
-              <a:rPr sz="900">
-                <a:solidFill>
-                  <a:srgbClr val="2D2D2D"/>
-                </a:solidFill>
-                <a:latin typeface="Consolas"/>
-              </a:rPr>
-              <a:t>./exercises/load.sh</a:t>
-            </a:r>
-            <a:r>
-              <a:rPr sz="900">
-                <a:solidFill>
-                  <a:srgbClr val="2D2D2D"/>
-                </a:solidFill>
-                <a:latin typeface="Consolas"/>
-              </a:rPr>
-              <a:t> contact-request basics/extending-core-modules/complete</a:t>
+              <a:spcAft>
+                <a:spcPts val="800"/>
+              </a:spcAft>
+              <a:defRPr sz="1600">
+                <a:solidFill>
+                  <a:srgbClr val="1A1A1A"/>
+                </a:solidFill>
+              </a:defRPr>
+            </a:pPr>
+            <a:r>
+              <a:t>Run the automated tests for this exercise:</a:t>
+            </a:r>
+          </a:p>
+          <a:p>
+            <a:pPr>
+              <a:spcBef>
+                <a:spcPts val="0"/>
+              </a:spcBef>
+              <a:spcAft>
+                <a:spcPts val="0"/>
+              </a:spcAft>
+            </a:pPr>
+            <a:r>
+              <a:rPr sz="900">
+                <a:solidFill>
+                  <a:srgbClr val="2D2D2D"/>
+                </a:solidFill>
+                <a:latin typeface="Consolas"/>
+              </a:rPr>
+              <a:t>docker/sdk</a:t>
+            </a:r>
+            <a:r>
+              <a:rPr sz="900">
+                <a:solidFill>
+                  <a:srgbClr val="2D2D2D"/>
+                </a:solidFill>
+                <a:latin typeface="Consolas"/>
+              </a:rPr>
+              <a:t> cli vendor/bin/codecept run </a:t>
+            </a:r>
+            <a:r>
+              <a:rPr sz="900">
+                <a:solidFill>
+                  <a:srgbClr val="2D2D2D"/>
+                </a:solidFill>
+                <a:latin typeface="Consolas"/>
+              </a:rPr>
+              <a:t>-c</a:t>
+            </a:r>
+            <a:r>
+              <a:rPr sz="900">
+                <a:solidFill>
+                  <a:srgbClr val="2D2D2D"/>
+                </a:solidFill>
+                <a:latin typeface="Consolas"/>
+              </a:rPr>
+              <a:t> tests/SprykerAcademyTest/Zed/ContactRequest/ Exercise7</a:t>
+            </a:r>
+          </a:p>
+          <a:p>
+            <a:pPr>
+              <a:spcAft>
+                <a:spcPts val="800"/>
+              </a:spcAft>
+              <a:defRPr sz="1600">
+                <a:solidFill>
+                  <a:srgbClr val="1A1A1A"/>
+                </a:solidFill>
+              </a:defRPr>
+            </a:pPr>
+            <a:r>
+              <a:t>The test suite covers: - Schema XML: fk_customer column, foreign key, timestampable behavior - Transfer XML: fkCustomer , createdAt properties, ContactRequestCollection transfer ( strict="true" , singular="contactRequest" ) - Structural: All classes and methods exist across the full stack - Mock-based: Stub calls the correct gateway paths for create, get, and delete - Unit: ContactRequestDeleter delegates to EntityManager correctly - SOLID: ContactRequestWriter does NOT have a delete() method</a:t>
+            </a:r>
+          </a:p>
+          <a:p>
+            <a:pPr>
+              <a:spcAft>
+                <a:spcPts val="800"/>
+              </a:spcAft>
+              <a:defRPr sz="1600">
+                <a:solidFill>
+                  <a:srgbClr val="1A1A1A"/>
+                </a:solidFill>
+              </a:defRPr>
+            </a:pPr>
+            <a:r>
+              <a:t>Or run all exercise tests at once:</a:t>
+            </a:r>
+          </a:p>
+          <a:p>
+            <a:pPr>
+              <a:spcBef>
+                <a:spcPts val="0"/>
+              </a:spcBef>
+              <a:spcAft>
+                <a:spcPts val="0"/>
+              </a:spcAft>
+            </a:pPr>
+            <a:r>
+              <a:rPr sz="900">
+                <a:solidFill>
+                  <a:srgbClr val="2D2D2D"/>
+                </a:solidFill>
+                <a:latin typeface="Consolas"/>
+              </a:rPr>
+              <a:t>docker/sdk</a:t>
+            </a:r>
+            <a:r>
+              <a:rPr sz="900">
+                <a:solidFill>
+                  <a:srgbClr val="2D2D2D"/>
+                </a:solidFill>
+                <a:latin typeface="Consolas"/>
+              </a:rPr>
+              <a:t> cli vendor/bin/codecept run </a:t>
+            </a:r>
+            <a:r>
+              <a:rPr sz="900">
+                <a:solidFill>
+                  <a:srgbClr val="2D2D2D"/>
+                </a:solidFill>
+                <a:latin typeface="Consolas"/>
+              </a:rPr>
+              <a:t>-c</a:t>
+            </a:r>
+            <a:r>
+              <a:rPr sz="900">
+                <a:solidFill>
+                  <a:srgbClr val="2D2D2D"/>
+                </a:solidFill>
+                <a:latin typeface="Consolas"/>
+              </a:rPr>
+              <a:t> tests/SprykerAcademyTest/Zed/ContactRequest/</a:t>
             </a:r>
           </a:p>
         </p:txBody>
@@ -32344,7 +32362,7 @@
               </a:defRPr>
             </a:pPr>
             <a:r>
-              <a:t>Bonus: AJAX Version</a:t>
+              <a:t>Solution</a:t>
             </a:r>
           </a:p>
         </p:txBody>
@@ -32415,146 +32433,30 @@
           <a:lstStyle/>
           <a:p>
             <a:pPr>
-              <a:spcAft>
-                <a:spcPts val="800"/>
-              </a:spcAft>
-              <a:defRPr sz="1600">
-                <a:solidFill>
-                  <a:srgbClr val="1A1A1A"/>
-                </a:solidFill>
-              </a:defRPr>
-            </a:pPr>
-            <a:r>
-              <a:t>An extended solution is available that uses Spryker’s built-in AJAX component pattern to add and delete messages without a full page reload. The message table refreshes dynamically.</a:t>
-            </a:r>
-          </a:p>
-          <a:p>
-            <a:pPr>
-              <a:spcBef>
-                <a:spcPts val="1200"/>
-              </a:spcBef>
-              <a:spcAft>
-                <a:spcPts val="600"/>
-              </a:spcAft>
-              <a:defRPr sz="2000" b="1">
-                <a:solidFill>
-                  <a:srgbClr val="1A1A1A"/>
-                </a:solidFill>
-              </a:defRPr>
-            </a:pPr>
-            <a:r>
-              <a:t>How Spryker AJAX Works</a:t>
-            </a:r>
-          </a:p>
-          <a:p>
-            <a:pPr>
-              <a:spcAft>
-                <a:spcPts val="800"/>
-              </a:spcAft>
-              <a:defRPr sz="1600">
-                <a:solidFill>
-                  <a:srgbClr val="1A1A1A"/>
-                </a:solidFill>
-              </a:defRPr>
-            </a:pPr>
-            <a:r>
-              <a:t>Spryker provides a component-based AJAX pattern using four Twig molecules from ShopUi :</a:t>
-            </a:r>
-          </a:p>
-          <a:p>
-            <a:pPr>
-              <a:spcAft>
-                <a:spcPts val="100"/>
-              </a:spcAft>
-              <a:defRPr sz="1000">
-                <a:solidFill>
-                  <a:srgbClr val="1A1A1A"/>
-                </a:solidFill>
-                <a:latin typeface="Consolas"/>
-              </a:defRPr>
-            </a:pPr>
-            <a:r>
-              <a:t>Component            Role                                                                                              </a:t>
-            </a:r>
-          </a:p>
-          <a:p>
-            <a:pPr>
-              <a:spcAft>
-                <a:spcPts val="100"/>
-              </a:spcAft>
-              <a:defRPr sz="1000">
-                <a:solidFill>
-                  <a:srgbClr val="1A1A1A"/>
-                </a:solidFill>
-                <a:latin typeface="Consolas"/>
-              </a:defRPr>
-            </a:pPr>
-            <a:r>
-              <a:t>-------------------  --------------------------------------------------------------------------------------------------</a:t>
-            </a:r>
-          </a:p>
-          <a:p>
-            <a:pPr>
-              <a:spcAft>
-                <a:spcPts val="100"/>
-              </a:spcAft>
-              <a:defRPr sz="1000">
-                <a:solidFill>
-                  <a:srgbClr val="1A1A1A"/>
-                </a:solidFill>
-                <a:latin typeface="Consolas"/>
-              </a:defRPr>
-            </a:pPr>
-            <a:r>
-              <a:t>ajax-provider        XMLHttpRequest wrapper — sends requests and dispatches fetching / fetched events                  </a:t>
-            </a:r>
-          </a:p>
-          <a:p>
-            <a:pPr>
-              <a:spcAft>
-                <a:spcPts val="100"/>
-              </a:spcAft>
-              <a:defRPr sz="1000">
-                <a:solidFill>
-                  <a:srgbClr val="1A1A1A"/>
-                </a:solidFill>
-                <a:latin typeface="Consolas"/>
-              </a:defRPr>
-            </a:pPr>
-            <a:r>
-              <a:t>ajax-form-submitter  Intercepts form submit (via data-* trigger attribute) and delegates to the provider               </a:t>
-            </a:r>
-          </a:p>
-          <a:p>
-            <a:pPr>
-              <a:spcAft>
-                <a:spcPts val="100"/>
-              </a:spcAft>
-              <a:defRPr sz="1000">
-                <a:solidFill>
-                  <a:srgbClr val="1A1A1A"/>
-                </a:solidFill>
-                <a:latin typeface="Consolas"/>
-              </a:defRPr>
-            </a:pPr>
-            <a:r>
-              <a:t>ajax-renderer        Listens for the fetched event, parses JSON response, and inserts content into a target DOM element</a:t>
-            </a:r>
-          </a:p>
-          <a:p>
-            <a:pPr>
-              <a:spcAft>
-                <a:spcPts val="100"/>
-              </a:spcAft>
-              <a:defRPr sz="1000">
-                <a:solidFill>
-                  <a:srgbClr val="1A1A1A"/>
-                </a:solidFill>
-                <a:latin typeface="Consolas"/>
-              </a:defRPr>
-            </a:pPr>
-            <a:r>
-              <a:t>ajax-loader          Shows/hides a spinner during the request</a:t>
+              <a:spcBef>
+                <a:spcPts val="0"/>
+              </a:spcBef>
+              <a:spcAft>
+                <a:spcPts val="0"/>
+              </a:spcAft>
+            </a:pPr>
+            <a:r>
+              <a:rPr sz="900">
+                <a:solidFill>
+                  <a:srgbClr val="2D2D2D"/>
+                </a:solidFill>
+                <a:latin typeface="Consolas"/>
+              </a:rPr>
+              <a:t>./exercises/load.sh</a:t>
+            </a:r>
+            <a:r>
+              <a:rPr sz="900">
+                <a:solidFill>
+                  <a:srgbClr val="2D2D2D"/>
+                </a:solidFill>
+                <a:latin typeface="Consolas"/>
+              </a:rPr>
+              <a:t> contact-request basics/extending-core-modules/complete</a:t>
             </a:r>
           </a:p>
         </p:txBody>
@@ -32607,7 +32509,7 @@
               </a:defRPr>
             </a:pPr>
             <a:r>
-              <a:t>The JSON Response Contract</a:t>
+              <a:t>Bonus: AJAX Version</a:t>
             </a:r>
           </a:p>
         </p:txBody>
@@ -32688,227 +32590,136 @@
               </a:defRPr>
             </a:pPr>
             <a:r>
-              <a:t>Async controllers return JsonResponse with this structure:</a:t>
-            </a:r>
-          </a:p>
-          <a:p>
-            <a:pPr>
-              <a:spcBef>
-                <a:spcPts val="0"/>
-              </a:spcBef>
-              <a:spcAft>
-                <a:spcPts val="0"/>
-              </a:spcAft>
-            </a:pPr>
-            <a:r>
-              <a:rPr sz="900">
-                <a:solidFill>
-                  <a:srgbClr val="06287E"/>
-                </a:solidFill>
-                <a:latin typeface="Consolas"/>
-              </a:rPr>
-              <a:t>{</a:t>
-            </a:r>
-          </a:p>
-          <a:p>
-            <a:pPr>
-              <a:spcBef>
-                <a:spcPts val="0"/>
-              </a:spcBef>
-              <a:spcAft>
-                <a:spcPts val="0"/>
-              </a:spcAft>
-            </a:pPr>
-            <a:r>
-              <a:rPr sz="900">
-                <a:solidFill>
-                  <a:srgbClr val="2D2D2D"/>
-                </a:solidFill>
-                <a:latin typeface="Consolas"/>
-              </a:rPr>
-              <a:t>    </a:t>
-            </a:r>
-            <a:r>
-              <a:rPr sz="900">
-                <a:solidFill>
-                  <a:srgbClr val="902000"/>
-                </a:solidFill>
-                <a:latin typeface="Consolas"/>
-              </a:rPr>
-              <a:t>"messages"</a:t>
-            </a:r>
-            <a:r>
-              <a:rPr sz="900">
-                <a:solidFill>
-                  <a:srgbClr val="06287E"/>
-                </a:solidFill>
-                <a:latin typeface="Consolas"/>
-              </a:rPr>
-              <a:t>:</a:t>
-            </a:r>
-            <a:r>
-              <a:rPr sz="900">
-                <a:solidFill>
-                  <a:srgbClr val="2D2D2D"/>
-                </a:solidFill>
-                <a:latin typeface="Consolas"/>
-              </a:rPr>
-              <a:t> </a:t>
-            </a:r>
-            <a:r>
-              <a:rPr sz="900">
-                <a:solidFill>
-                  <a:srgbClr val="4070A0"/>
-                </a:solidFill>
-                <a:latin typeface="Consolas"/>
-              </a:rPr>
-              <a:t>"&lt;rendered flash message HTML&gt;"</a:t>
-            </a:r>
-            <a:r>
-              <a:rPr sz="900">
-                <a:solidFill>
-                  <a:srgbClr val="06287E"/>
-                </a:solidFill>
-                <a:latin typeface="Consolas"/>
-              </a:rPr>
-              <a:t>,</a:t>
-            </a:r>
-          </a:p>
-          <a:p>
-            <a:pPr>
-              <a:spcBef>
-                <a:spcPts val="0"/>
-              </a:spcBef>
-              <a:spcAft>
-                <a:spcPts val="0"/>
-              </a:spcAft>
-            </a:pPr>
-            <a:r>
-              <a:rPr sz="900">
-                <a:solidFill>
-                  <a:srgbClr val="2D2D2D"/>
-                </a:solidFill>
-                <a:latin typeface="Consolas"/>
-              </a:rPr>
-              <a:t>    </a:t>
-            </a:r>
-            <a:r>
-              <a:rPr sz="900">
-                <a:solidFill>
-                  <a:srgbClr val="902000"/>
-                </a:solidFill>
-                <a:latin typeface="Consolas"/>
-              </a:rPr>
-              <a:t>"content"</a:t>
-            </a:r>
-            <a:r>
-              <a:rPr sz="900">
-                <a:solidFill>
-                  <a:srgbClr val="06287E"/>
-                </a:solidFill>
-                <a:latin typeface="Consolas"/>
-              </a:rPr>
-              <a:t>:</a:t>
-            </a:r>
-            <a:r>
-              <a:rPr sz="900">
-                <a:solidFill>
-                  <a:srgbClr val="2D2D2D"/>
-                </a:solidFill>
-                <a:latin typeface="Consolas"/>
-              </a:rPr>
-              <a:t> </a:t>
-            </a:r>
-            <a:r>
-              <a:rPr sz="900">
-                <a:solidFill>
-                  <a:srgbClr val="4070A0"/>
-                </a:solidFill>
-                <a:latin typeface="Consolas"/>
-              </a:rPr>
-              <a:t>"&lt;rendered HTML fragment to replace in the DOM&gt;"</a:t>
-            </a:r>
-          </a:p>
-          <a:p>
-            <a:pPr>
-              <a:spcBef>
-                <a:spcPts val="0"/>
-              </a:spcBef>
-              <a:spcAft>
-                <a:spcPts val="0"/>
-              </a:spcAft>
-            </a:pPr>
-            <a:r>
-              <a:rPr sz="900">
-                <a:solidFill>
-                  <a:srgbClr val="06287E"/>
-                </a:solidFill>
-                <a:latin typeface="Consolas"/>
-              </a:rPr>
-              <a:t>}</a:t>
-            </a:r>
-          </a:p>
-          <a:p>
-            <a:pPr>
-              <a:spcAft>
-                <a:spcPts val="400"/>
-              </a:spcAft>
-              <a:defRPr sz="1500">
+              <a:t>An extended solution is available that uses Spryker’s built-in AJAX component pattern to add and delete messages without a full page reload. The message table refreshes dynamically.</a:t>
+            </a:r>
+          </a:p>
+          <a:p>
+            <a:pPr>
+              <a:spcBef>
+                <a:spcPts val="1200"/>
+              </a:spcBef>
+              <a:spcAft>
+                <a:spcPts val="600"/>
+              </a:spcAft>
+              <a:defRPr sz="2000" b="1">
                 <a:solidFill>
                   <a:srgbClr val="1A1A1A"/>
                 </a:solidFill>
               </a:defRPr>
             </a:pPr>
             <a:r>
-              <a:t>• messages — Rendered via @ShopUi/components/organisms/flash-message-list/flash-message-list.twig . Dispatched as a DOM event for the flash message component to pick up.</a:t>
-            </a:r>
-          </a:p>
-          <a:p>
-            <a:pPr>
-              <a:spcAft>
-                <a:spcPts val="400"/>
-              </a:spcAft>
-              <a:defRPr sz="1500">
+              <a:t>How Spryker AJAX Works</a:t>
+            </a:r>
+          </a:p>
+          <a:p>
+            <a:pPr>
+              <a:spcAft>
+                <a:spcPts val="800"/>
+              </a:spcAft>
+              <a:defRPr sz="1600">
                 <a:solidFill>
                   <a:srgbClr val="1A1A1A"/>
                 </a:solidFill>
               </a:defRPr>
             </a:pPr>
             <a:r>
-              <a:t>• content — The re-rendered page fragment. The ajax-renderer inserts this into the target element.</a:t>
-            </a:r>
-          </a:p>
-          <a:p>
-            <a:pPr>
-              <a:spcBef>
-                <a:spcPts val="1200"/>
-              </a:spcBef>
-              <a:spcAft>
-                <a:spcPts val="600"/>
-              </a:spcAft>
-              <a:defRPr sz="2000" b="1">
+              <a:t>Spryker provides a component-based AJAX pattern using four Twig molecules from ShopUi :</a:t>
+            </a:r>
+          </a:p>
+          <a:p>
+            <a:pPr>
+              <a:spcAft>
+                <a:spcPts val="100"/>
+              </a:spcAft>
+              <a:defRPr sz="1000">
                 <a:solidFill>
                   <a:srgbClr val="1A1A1A"/>
                 </a:solidFill>
-              </a:defRPr>
-            </a:pPr>
-            <a:r>
-              <a:t>Twig Integration</a:t>
-            </a:r>
-          </a:p>
-          <a:p>
-            <a:pPr>
-              <a:spcAft>
-                <a:spcPts val="800"/>
-              </a:spcAft>
-              <a:defRPr sz="1600">
+                <a:latin typeface="Consolas"/>
+              </a:defRPr>
+            </a:pPr>
+            <a:r>
+              <a:t>Component            Role                                                                                              </a:t>
+            </a:r>
+          </a:p>
+          <a:p>
+            <a:pPr>
+              <a:spcAft>
+                <a:spcPts val="100"/>
+              </a:spcAft>
+              <a:defRPr sz="1000">
                 <a:solidFill>
                   <a:srgbClr val="1A1A1A"/>
                 </a:solidFill>
-              </a:defRPr>
-            </a:pPr>
-            <a:r>
-              <a:t>The template includes the AJAX trio after the content wrapper:</a:t>
+                <a:latin typeface="Consolas"/>
+              </a:defRPr>
+            </a:pPr>
+            <a:r>
+              <a:t>-------------------  --------------------------------------------------------------------------------------------------</a:t>
+            </a:r>
+          </a:p>
+          <a:p>
+            <a:pPr>
+              <a:spcAft>
+                <a:spcPts val="100"/>
+              </a:spcAft>
+              <a:defRPr sz="1000">
+                <a:solidFill>
+                  <a:srgbClr val="1A1A1A"/>
+                </a:solidFill>
+                <a:latin typeface="Consolas"/>
+              </a:defRPr>
+            </a:pPr>
+            <a:r>
+              <a:t>ajax-provider        XMLHttpRequest wrapper — sends requests and dispatches fetching / fetched events                  </a:t>
+            </a:r>
+          </a:p>
+          <a:p>
+            <a:pPr>
+              <a:spcAft>
+                <a:spcPts val="100"/>
+              </a:spcAft>
+              <a:defRPr sz="1000">
+                <a:solidFill>
+                  <a:srgbClr val="1A1A1A"/>
+                </a:solidFill>
+                <a:latin typeface="Consolas"/>
+              </a:defRPr>
+            </a:pPr>
+            <a:r>
+              <a:t>ajax-form-submitter  Intercepts form submit (via data-* trigger attribute) and delegates to the provider               </a:t>
+            </a:r>
+          </a:p>
+          <a:p>
+            <a:pPr>
+              <a:spcAft>
+                <a:spcPts val="100"/>
+              </a:spcAft>
+              <a:defRPr sz="1000">
+                <a:solidFill>
+                  <a:srgbClr val="1A1A1A"/>
+                </a:solidFill>
+                <a:latin typeface="Consolas"/>
+              </a:defRPr>
+            </a:pPr>
+            <a:r>
+              <a:t>ajax-renderer        Listens for the fetched event, parses JSON response, and inserts content into a target DOM element</a:t>
+            </a:r>
+          </a:p>
+          <a:p>
+            <a:pPr>
+              <a:spcAft>
+                <a:spcPts val="100"/>
+              </a:spcAft>
+              <a:defRPr sz="1000">
+                <a:solidFill>
+                  <a:srgbClr val="1A1A1A"/>
+                </a:solidFill>
+                <a:latin typeface="Consolas"/>
+              </a:defRPr>
+            </a:pPr>
+            <a:r>
+              <a:t>ajax-loader          Shows/hides a spinner during the request</a:t>
             </a:r>
           </a:p>
         </p:txBody>
@@ -32961,7 +32772,7 @@
               </a:defRPr>
             </a:pPr>
             <a:r>
-              <a:t>The JSON Response Contract (cont.)</a:t>
+              <a:t>The JSON Response Contract</a:t>
             </a:r>
           </a:p>
         </p:txBody>
@@ -33032,170 +32843,222 @@
           <a:lstStyle/>
           <a:p>
             <a:pPr>
-              <a:spcBef>
-                <a:spcPts val="0"/>
-              </a:spcBef>
-              <a:spcAft>
-                <a:spcPts val="0"/>
-              </a:spcAft>
-            </a:pPr>
-            <a:r>
-              <a:rPr sz="900">
-                <a:solidFill>
-                  <a:srgbClr val="2D2D2D"/>
-                </a:solidFill>
-                <a:latin typeface="Consolas"/>
-              </a:rPr>
-              <a:t>{# Content area that gets replaced #}</a:t>
-            </a:r>
-          </a:p>
-          <a:p>
-            <a:pPr>
-              <a:spcBef>
-                <a:spcPts val="0"/>
-              </a:spcBef>
-              <a:spcAft>
-                <a:spcPts val="0"/>
-              </a:spcAft>
-            </a:pPr>
-            <a:r>
-              <a:rPr sz="900">
-                <a:solidFill>
-                  <a:srgbClr val="2D2D2D"/>
-                </a:solidFill>
-                <a:latin typeface="Consolas"/>
-              </a:rPr>
-              <a:t>&lt;div class="{{ ajaxContentClass }}"&gt;</a:t>
-            </a:r>
-          </a:p>
-          <a:p>
-            <a:pPr>
-              <a:spcBef>
-                <a:spcPts val="0"/>
-              </a:spcBef>
-              <a:spcAft>
-                <a:spcPts val="0"/>
-              </a:spcAft>
-            </a:pPr>
-            <a:r>
-              <a:rPr sz="900">
-                <a:solidFill>
-                  <a:srgbClr val="2D2D2D"/>
-                </a:solidFill>
-                <a:latin typeface="Consolas"/>
-              </a:rPr>
-              <a:t>    {# ... table, form, loader ... #}</a:t>
-            </a:r>
-          </a:p>
-          <a:p>
-            <a:pPr>
-              <a:spcBef>
-                <a:spcPts val="0"/>
-              </a:spcBef>
-              <a:spcAft>
-                <a:spcPts val="0"/>
-              </a:spcAft>
-            </a:pPr>
-            <a:r>
-              <a:rPr sz="900">
-                <a:solidFill>
-                  <a:srgbClr val="2D2D2D"/>
-                </a:solidFill>
-                <a:latin typeface="Consolas"/>
-              </a:rPr>
-              <a:t>&lt;/div&gt;</a:t>
-            </a:r>
-          </a:p>
-          <a:p>
-            <a:pPr>
-              <a:spcBef>
-                <a:spcPts val="0"/>
-              </a:spcBef>
-              <a:spcAft>
-                <a:spcPts val="0"/>
-              </a:spcAft>
-            </a:pPr>
-            <a:r>
-              <a:rPr sz="900">
+              <a:spcAft>
+                <a:spcPts val="800"/>
+              </a:spcAft>
+              <a:defRPr sz="1600">
+                <a:solidFill>
+                  <a:srgbClr val="1A1A1A"/>
+                </a:solidFill>
+              </a:defRPr>
+            </a:pPr>
+            <a:r>
+              <a:t>Async controllers return JsonResponse with this structure:</a:t>
+            </a:r>
+          </a:p>
+          <a:p>
+            <a:pPr>
+              <a:spcBef>
+                <a:spcPts val="0"/>
+              </a:spcBef>
+              <a:spcAft>
+                <a:spcPts val="0"/>
+              </a:spcAft>
+            </a:pPr>
+            <a:r>
+              <a:rPr sz="900">
+                <a:solidFill>
+                  <a:srgbClr val="06287E"/>
+                </a:solidFill>
+                <a:latin typeface="Consolas"/>
+              </a:rPr>
+              <a:t>{</a:t>
+            </a:r>
+          </a:p>
+          <a:p>
+            <a:pPr>
+              <a:spcBef>
+                <a:spcPts val="0"/>
+              </a:spcBef>
+              <a:spcAft>
+                <a:spcPts val="0"/>
+              </a:spcAft>
+            </a:pPr>
+            <a:r>
+              <a:rPr sz="900">
+                <a:solidFill>
+                  <a:srgbClr val="2D2D2D"/>
+                </a:solidFill>
+                <a:latin typeface="Consolas"/>
+              </a:rPr>
+              <a:t>    </a:t>
+            </a:r>
+            <a:r>
+              <a:rPr sz="900">
+                <a:solidFill>
+                  <a:srgbClr val="902000"/>
+                </a:solidFill>
+                <a:latin typeface="Consolas"/>
+              </a:rPr>
+              <a:t>"messages"</a:t>
+            </a:r>
+            <a:r>
+              <a:rPr sz="900">
+                <a:solidFill>
+                  <a:srgbClr val="06287E"/>
+                </a:solidFill>
+                <a:latin typeface="Consolas"/>
+              </a:rPr>
+              <a:t>:</a:t>
+            </a:r>
+            <a:r>
+              <a:rPr sz="900">
+                <a:solidFill>
+                  <a:srgbClr val="2D2D2D"/>
+                </a:solidFill>
                 <a:latin typeface="Consolas"/>
               </a:rPr>
               <a:t> </a:t>
             </a:r>
-          </a:p>
-          <a:p>
-            <a:pPr>
-              <a:spcBef>
-                <a:spcPts val="0"/>
-              </a:spcBef>
-              <a:spcAft>
-                <a:spcPts val="0"/>
-              </a:spcAft>
-            </a:pPr>
-            <a:r>
-              <a:rPr sz="900">
-                <a:solidFill>
-                  <a:srgbClr val="2D2D2D"/>
-                </a:solidFill>
-                <a:latin typeface="Consolas"/>
-              </a:rPr>
-              <a:t>{# AJAX components #}</a:t>
-            </a:r>
-          </a:p>
-          <a:p>
-            <a:pPr>
-              <a:spcBef>
-                <a:spcPts val="0"/>
-              </a:spcBef>
-              <a:spcAft>
-                <a:spcPts val="0"/>
-              </a:spcAft>
-            </a:pPr>
-            <a:r>
-              <a:rPr sz="900">
-                <a:solidFill>
-                  <a:srgbClr val="2D2D2D"/>
-                </a:solidFill>
-                <a:latin typeface="Consolas"/>
-              </a:rPr>
-              <a:t>{% include molecule('ajax-provider') with { class: ajaxProviderClass, attributes: { method: 'POST' } } only %}</a:t>
-            </a:r>
-          </a:p>
-          <a:p>
-            <a:pPr>
-              <a:spcBef>
-                <a:spcPts val="0"/>
-              </a:spcBef>
-              <a:spcAft>
-                <a:spcPts val="0"/>
-              </a:spcAft>
-            </a:pPr>
-            <a:r>
-              <a:rPr sz="900">
-                <a:solidFill>
-                  <a:srgbClr val="2D2D2D"/>
-                </a:solidFill>
-                <a:latin typeface="Consolas"/>
-              </a:rPr>
-              <a:t>{% include molecule('ajax-renderer') with { attributes: { 'provider-class-name': ajaxProviderClass, 'target-class-name': ajaxContentClass, 'mount-after-render': true } } only %}</a:t>
-            </a:r>
-          </a:p>
-          <a:p>
-            <a:pPr>
-              <a:spcBef>
-                <a:spcPts val="0"/>
-              </a:spcBef>
-              <a:spcAft>
-                <a:spcPts val="0"/>
-              </a:spcAft>
-            </a:pPr>
-            <a:r>
-              <a:rPr sz="900">
-                <a:solidFill>
-                  <a:srgbClr val="2D2D2D"/>
-                </a:solidFill>
-                <a:latin typeface="Consolas"/>
-              </a:rPr>
-              <a:t>{% include molecule('ajax-form-submitter') with { attributes: { 'trigger-attribute': 'data-contact-request-ajax-submit', 'provider-class-name': ajaxProviderClass } } only %}</a:t>
+            <a:r>
+              <a:rPr sz="900">
+                <a:solidFill>
+                  <a:srgbClr val="4070A0"/>
+                </a:solidFill>
+                <a:latin typeface="Consolas"/>
+              </a:rPr>
+              <a:t>"&lt;rendered flash message HTML&gt;"</a:t>
+            </a:r>
+            <a:r>
+              <a:rPr sz="900">
+                <a:solidFill>
+                  <a:srgbClr val="06287E"/>
+                </a:solidFill>
+                <a:latin typeface="Consolas"/>
+              </a:rPr>
+              <a:t>,</a:t>
+            </a:r>
+          </a:p>
+          <a:p>
+            <a:pPr>
+              <a:spcBef>
+                <a:spcPts val="0"/>
+              </a:spcBef>
+              <a:spcAft>
+                <a:spcPts val="0"/>
+              </a:spcAft>
+            </a:pPr>
+            <a:r>
+              <a:rPr sz="900">
+                <a:solidFill>
+                  <a:srgbClr val="2D2D2D"/>
+                </a:solidFill>
+                <a:latin typeface="Consolas"/>
+              </a:rPr>
+              <a:t>    </a:t>
+            </a:r>
+            <a:r>
+              <a:rPr sz="900">
+                <a:solidFill>
+                  <a:srgbClr val="902000"/>
+                </a:solidFill>
+                <a:latin typeface="Consolas"/>
+              </a:rPr>
+              <a:t>"content"</a:t>
+            </a:r>
+            <a:r>
+              <a:rPr sz="900">
+                <a:solidFill>
+                  <a:srgbClr val="06287E"/>
+                </a:solidFill>
+                <a:latin typeface="Consolas"/>
+              </a:rPr>
+              <a:t>:</a:t>
+            </a:r>
+            <a:r>
+              <a:rPr sz="900">
+                <a:solidFill>
+                  <a:srgbClr val="2D2D2D"/>
+                </a:solidFill>
+                <a:latin typeface="Consolas"/>
+              </a:rPr>
+              <a:t> </a:t>
+            </a:r>
+            <a:r>
+              <a:rPr sz="900">
+                <a:solidFill>
+                  <a:srgbClr val="4070A0"/>
+                </a:solidFill>
+                <a:latin typeface="Consolas"/>
+              </a:rPr>
+              <a:t>"&lt;rendered HTML fragment to replace in the DOM&gt;"</a:t>
+            </a:r>
+          </a:p>
+          <a:p>
+            <a:pPr>
+              <a:spcBef>
+                <a:spcPts val="0"/>
+              </a:spcBef>
+              <a:spcAft>
+                <a:spcPts val="0"/>
+              </a:spcAft>
+            </a:pPr>
+            <a:r>
+              <a:rPr sz="900">
+                <a:solidFill>
+                  <a:srgbClr val="06287E"/>
+                </a:solidFill>
+                <a:latin typeface="Consolas"/>
+              </a:rPr>
+              <a:t>}</a:t>
+            </a:r>
+          </a:p>
+          <a:p>
+            <a:pPr>
+              <a:spcAft>
+                <a:spcPts val="400"/>
+              </a:spcAft>
+              <a:defRPr sz="1500">
+                <a:solidFill>
+                  <a:srgbClr val="1A1A1A"/>
+                </a:solidFill>
+              </a:defRPr>
+            </a:pPr>
+            <a:r>
+              <a:t>• messages — Rendered via @ShopUi/components/organisms/flash-message-list/flash-message-list.twig . Dispatched as a DOM event for the flash message component to pick up.</a:t>
+            </a:r>
+          </a:p>
+          <a:p>
+            <a:pPr>
+              <a:spcAft>
+                <a:spcPts val="400"/>
+              </a:spcAft>
+              <a:defRPr sz="1500">
+                <a:solidFill>
+                  <a:srgbClr val="1A1A1A"/>
+                </a:solidFill>
+              </a:defRPr>
+            </a:pPr>
+            <a:r>
+              <a:t>• content — The re-rendered page fragment. The ajax-renderer inserts this into the target element.</a:t>
+            </a:r>
+          </a:p>
+          <a:p>
+            <a:pPr>
+              <a:spcBef>
+                <a:spcPts val="1200"/>
+              </a:spcBef>
+              <a:spcAft>
+                <a:spcPts val="600"/>
+              </a:spcAft>
+              <a:defRPr sz="2000" b="1">
+                <a:solidFill>
+                  <a:srgbClr val="1A1A1A"/>
+                </a:solidFill>
+              </a:defRPr>
+            </a:pPr>
+            <a:r>
+              <a:t>Twig Integration</a:t>
             </a:r>
           </a:p>
           <a:p>
@@ -33210,135 +33073,7 @@
               </a:defRPr>
             </a:pPr>
             <a:r>
-              <a:t>Form buttons use data-contact-request-ajax-submit and formaction to point to the async endpoint:</a:t>
-            </a:r>
-          </a:p>
-          <a:p>
-            <a:pPr>
-              <a:spcBef>
-                <a:spcPts val="0"/>
-              </a:spcBef>
-              <a:spcAft>
-                <a:spcPts val="0"/>
-              </a:spcAft>
-            </a:pPr>
-            <a:r>
-              <a:rPr sz="900" b="1">
-                <a:solidFill>
-                  <a:srgbClr val="007020"/>
-                </a:solidFill>
-                <a:latin typeface="Consolas"/>
-              </a:rPr>
-              <a:t>&lt;button</a:t>
-            </a:r>
-            <a:r>
-              <a:rPr sz="900">
-                <a:solidFill>
-                  <a:srgbClr val="007020"/>
-                </a:solidFill>
-                <a:latin typeface="Consolas"/>
-              </a:rPr>
-              <a:t> data-contact-request-ajax-submit formaction=</a:t>
-            </a:r>
-            <a:r>
-              <a:rPr sz="900">
-                <a:solidFill>
-                  <a:srgbClr val="4070A0"/>
-                </a:solidFill>
-                <a:latin typeface="Consolas"/>
-              </a:rPr>
-              <a:t>"/customer/contact-requests/async/add"</a:t>
-            </a:r>
-            <a:r>
-              <a:rPr sz="900" b="1">
-                <a:solidFill>
-                  <a:srgbClr val="007020"/>
-                </a:solidFill>
-                <a:latin typeface="Consolas"/>
-              </a:rPr>
-              <a:t>&gt;</a:t>
-            </a:r>
-            <a:r>
-              <a:rPr sz="900">
-                <a:solidFill>
-                  <a:srgbClr val="2D2D2D"/>
-                </a:solidFill>
-                <a:latin typeface="Consolas"/>
-              </a:rPr>
-              <a:t>Add Contact Request</a:t>
-            </a:r>
-            <a:r>
-              <a:rPr sz="900" b="1">
-                <a:solidFill>
-                  <a:srgbClr val="007020"/>
-                </a:solidFill>
-                <a:latin typeface="Consolas"/>
-              </a:rPr>
-              <a:t>&lt;/button&gt;</a:t>
-            </a:r>
-          </a:p>
-          <a:p>
-            <a:pPr>
-              <a:spcBef>
-                <a:spcPts val="0"/>
-              </a:spcBef>
-              <a:spcAft>
-                <a:spcPts val="0"/>
-              </a:spcAft>
-            </a:pPr>
-            <a:r>
-              <a:rPr sz="900" b="1">
-                <a:solidFill>
-                  <a:srgbClr val="007020"/>
-                </a:solidFill>
-                <a:latin typeface="Consolas"/>
-              </a:rPr>
-              <a:t>&lt;button</a:t>
-            </a:r>
-            <a:r>
-              <a:rPr sz="900">
-                <a:solidFill>
-                  <a:srgbClr val="007020"/>
-                </a:solidFill>
-                <a:latin typeface="Consolas"/>
-              </a:rPr>
-              <a:t> data-contact-request-ajax-submit formaction=</a:t>
-            </a:r>
-            <a:r>
-              <a:rPr sz="900">
-                <a:solidFill>
-                  <a:srgbClr val="4070A0"/>
-                </a:solidFill>
-                <a:latin typeface="Consolas"/>
-              </a:rPr>
-              <a:t>"/customer/contact-requests/async/delete"</a:t>
-            </a:r>
-            <a:r>
-              <a:rPr sz="900" b="1">
-                <a:solidFill>
-                  <a:srgbClr val="007020"/>
-                </a:solidFill>
-                <a:latin typeface="Consolas"/>
-              </a:rPr>
-              <a:t>&gt;</a:t>
-            </a:r>
-            <a:r>
-              <a:rPr sz="900">
-                <a:solidFill>
-                  <a:srgbClr val="2D2D2D"/>
-                </a:solidFill>
-                <a:latin typeface="Consolas"/>
-              </a:rPr>
-              <a:t>Delete</a:t>
-            </a:r>
-            <a:r>
-              <a:rPr sz="900" b="1">
-                <a:solidFill>
-                  <a:srgbClr val="007020"/>
-                </a:solidFill>
-                <a:latin typeface="Consolas"/>
-              </a:rPr>
-              <a:t>&lt;/button&gt;</a:t>
+              <a:t>The template includes the AJAX trio after the content wrapper:</a:t>
             </a:r>
           </a:p>
         </p:txBody>
@@ -33352,6 +33087,436 @@
 </file>
 
 <file path=ppt/slides/slide206.xml><?xml version="1.0" encoding="utf-8"?>
+<p:sld xmlns:a="http://schemas.openxmlformats.org/drawingml/2006/main" xmlns:p="http://schemas.openxmlformats.org/presentationml/2006/main" xmlns:r="http://schemas.openxmlformats.org/officeDocument/2006/relationships">
+  <p:cSld>
+    <p:spTree>
+      <p:nvGrpSpPr>
+        <p:cNvPr id="1" name=""/>
+        <p:cNvGrpSpPr/>
+        <p:nvPr/>
+      </p:nvGrpSpPr>
+      <p:grpSpPr/>
+      <p:sp>
+        <p:nvSpPr>
+          <p:cNvPr id="2" name="TextBox 1"/>
+          <p:cNvSpPr txBox="1"/>
+          <p:nvPr/>
+        </p:nvSpPr>
+        <p:spPr>
+          <a:xfrm>
+            <a:off x="640080" y="365760"/>
+            <a:ext cx="10881360" cy="731520"/>
+          </a:xfrm>
+          <a:prstGeom prst="rect">
+            <a:avLst/>
+          </a:prstGeom>
+          <a:noFill/>
+        </p:spPr>
+        <p:txBody>
+          <a:bodyPr wrap="square">
+            <a:spAutoFit/>
+          </a:bodyPr>
+          <a:lstStyle/>
+          <a:p>
+            <a:pPr>
+              <a:defRPr sz="2800" b="1">
+                <a:solidFill>
+                  <a:srgbClr val="00A89B"/>
+                </a:solidFill>
+              </a:defRPr>
+            </a:pPr>
+            <a:r>
+              <a:t>The JSON Response Contract (cont.)</a:t>
+            </a:r>
+          </a:p>
+        </p:txBody>
+      </p:sp>
+      <p:sp>
+        <p:nvSpPr>
+          <p:cNvPr id="3" name="Rectangle 2"/>
+          <p:cNvSpPr/>
+          <p:nvPr/>
+        </p:nvSpPr>
+        <p:spPr>
+          <a:xfrm>
+            <a:off x="640080" y="1051560"/>
+            <a:ext cx="1828800" cy="25400"/>
+          </a:xfrm>
+          <a:prstGeom prst="rect">
+            <a:avLst/>
+          </a:prstGeom>
+          <a:solidFill>
+            <a:srgbClr val="00A89B"/>
+          </a:solidFill>
+          <a:ln>
+            <a:noFill/>
+          </a:ln>
+        </p:spPr>
+        <p:style>
+          <a:lnRef idx="1">
+            <a:schemeClr val="accent1"/>
+          </a:lnRef>
+          <a:fillRef idx="3">
+            <a:schemeClr val="accent1"/>
+          </a:fillRef>
+          <a:effectRef idx="2">
+            <a:schemeClr val="accent1"/>
+          </a:effectRef>
+          <a:fontRef idx="minor">
+            <a:schemeClr val="lt1"/>
+          </a:fontRef>
+        </p:style>
+        <p:txBody>
+          <a:bodyPr rtlCol="0" anchor="ctr"/>
+          <a:lstStyle/>
+          <a:p>
+            <a:pPr algn="ctr"/>
+          </a:p>
+        </p:txBody>
+      </p:sp>
+      <p:sp>
+        <p:nvSpPr>
+          <p:cNvPr id="4" name="TextBox 3"/>
+          <p:cNvSpPr txBox="1"/>
+          <p:nvPr/>
+        </p:nvSpPr>
+        <p:spPr>
+          <a:xfrm>
+            <a:off x="640080" y="1371600"/>
+            <a:ext cx="10881360" cy="5029200"/>
+          </a:xfrm>
+          <a:prstGeom prst="rect">
+            <a:avLst/>
+          </a:prstGeom>
+          <a:noFill/>
+        </p:spPr>
+        <p:txBody>
+          <a:bodyPr wrap="square">
+            <a:spAutoFit/>
+          </a:bodyPr>
+          <a:lstStyle/>
+          <a:p>
+            <a:pPr>
+              <a:spcBef>
+                <a:spcPts val="0"/>
+              </a:spcBef>
+              <a:spcAft>
+                <a:spcPts val="0"/>
+              </a:spcAft>
+            </a:pPr>
+            <a:r>
+              <a:rPr sz="900">
+                <a:solidFill>
+                  <a:srgbClr val="2D2D2D"/>
+                </a:solidFill>
+                <a:latin typeface="Consolas"/>
+              </a:rPr>
+              <a:t>{# Content area that gets replaced #}</a:t>
+            </a:r>
+          </a:p>
+          <a:p>
+            <a:pPr>
+              <a:spcBef>
+                <a:spcPts val="0"/>
+              </a:spcBef>
+              <a:spcAft>
+                <a:spcPts val="0"/>
+              </a:spcAft>
+            </a:pPr>
+            <a:r>
+              <a:rPr sz="900">
+                <a:solidFill>
+                  <a:srgbClr val="2D2D2D"/>
+                </a:solidFill>
+                <a:latin typeface="Consolas"/>
+              </a:rPr>
+              <a:t>&lt;div class="{{ ajaxContentClass }}"&gt;</a:t>
+            </a:r>
+          </a:p>
+          <a:p>
+            <a:pPr>
+              <a:spcBef>
+                <a:spcPts val="0"/>
+              </a:spcBef>
+              <a:spcAft>
+                <a:spcPts val="0"/>
+              </a:spcAft>
+            </a:pPr>
+            <a:r>
+              <a:rPr sz="900">
+                <a:solidFill>
+                  <a:srgbClr val="2D2D2D"/>
+                </a:solidFill>
+                <a:latin typeface="Consolas"/>
+              </a:rPr>
+              <a:t>    {# ... table, form, loader ... #}</a:t>
+            </a:r>
+          </a:p>
+          <a:p>
+            <a:pPr>
+              <a:spcBef>
+                <a:spcPts val="0"/>
+              </a:spcBef>
+              <a:spcAft>
+                <a:spcPts val="0"/>
+              </a:spcAft>
+            </a:pPr>
+            <a:r>
+              <a:rPr sz="900">
+                <a:solidFill>
+                  <a:srgbClr val="2D2D2D"/>
+                </a:solidFill>
+                <a:latin typeface="Consolas"/>
+              </a:rPr>
+              <a:t>&lt;/div&gt;</a:t>
+            </a:r>
+          </a:p>
+          <a:p>
+            <a:pPr>
+              <a:spcBef>
+                <a:spcPts val="0"/>
+              </a:spcBef>
+              <a:spcAft>
+                <a:spcPts val="0"/>
+              </a:spcAft>
+            </a:pPr>
+            <a:r>
+              <a:rPr sz="900">
+                <a:latin typeface="Consolas"/>
+              </a:rPr>
+              <a:t> </a:t>
+            </a:r>
+          </a:p>
+          <a:p>
+            <a:pPr>
+              <a:spcBef>
+                <a:spcPts val="0"/>
+              </a:spcBef>
+              <a:spcAft>
+                <a:spcPts val="0"/>
+              </a:spcAft>
+            </a:pPr>
+            <a:r>
+              <a:rPr sz="900">
+                <a:solidFill>
+                  <a:srgbClr val="2D2D2D"/>
+                </a:solidFill>
+                <a:latin typeface="Consolas"/>
+              </a:rPr>
+              <a:t>{# AJAX components #}</a:t>
+            </a:r>
+          </a:p>
+          <a:p>
+            <a:pPr>
+              <a:spcBef>
+                <a:spcPts val="0"/>
+              </a:spcBef>
+              <a:spcAft>
+                <a:spcPts val="0"/>
+              </a:spcAft>
+            </a:pPr>
+            <a:r>
+              <a:rPr sz="900">
+                <a:solidFill>
+                  <a:srgbClr val="2D2D2D"/>
+                </a:solidFill>
+                <a:latin typeface="Consolas"/>
+              </a:rPr>
+              <a:t>{% include molecule('ajax-provider') with { class: ajaxProviderClass, attributes: { method: 'POST' } } only %}</a:t>
+            </a:r>
+          </a:p>
+          <a:p>
+            <a:pPr>
+              <a:spcBef>
+                <a:spcPts val="0"/>
+              </a:spcBef>
+              <a:spcAft>
+                <a:spcPts val="0"/>
+              </a:spcAft>
+            </a:pPr>
+            <a:r>
+              <a:rPr sz="900">
+                <a:solidFill>
+                  <a:srgbClr val="2D2D2D"/>
+                </a:solidFill>
+                <a:latin typeface="Consolas"/>
+              </a:rPr>
+              <a:t>{% include molecule('ajax-renderer') with { attributes: { 'provider-class-name': ajaxProviderClass, 'target-class-name': ajaxContentClass, 'mount-after-render': true } } only %}</a:t>
+            </a:r>
+          </a:p>
+          <a:p>
+            <a:pPr>
+              <a:spcBef>
+                <a:spcPts val="0"/>
+              </a:spcBef>
+              <a:spcAft>
+                <a:spcPts val="0"/>
+              </a:spcAft>
+            </a:pPr>
+            <a:r>
+              <a:rPr sz="900">
+                <a:solidFill>
+                  <a:srgbClr val="2D2D2D"/>
+                </a:solidFill>
+                <a:latin typeface="Consolas"/>
+              </a:rPr>
+              <a:t>{% include molecule('ajax-form-submitter') with { attributes: { 'trigger-attribute': 'data-contact-request-ajax-submit', 'provider-class-name': ajaxProviderClass } } only %}</a:t>
+            </a:r>
+          </a:p>
+          <a:p>
+            <a:pPr>
+              <a:spcAft>
+                <a:spcPts val="800"/>
+              </a:spcAft>
+              <a:defRPr sz="1600">
+                <a:solidFill>
+                  <a:srgbClr val="1A1A1A"/>
+                </a:solidFill>
+              </a:defRPr>
+            </a:pPr>
+            <a:r>
+              <a:t>Form buttons use data-contact-request-ajax-submit and formaction to point to the async endpoint:</a:t>
+            </a:r>
+          </a:p>
+          <a:p>
+            <a:pPr>
+              <a:spcBef>
+                <a:spcPts val="0"/>
+              </a:spcBef>
+              <a:spcAft>
+                <a:spcPts val="0"/>
+              </a:spcAft>
+            </a:pPr>
+            <a:r>
+              <a:rPr sz="900" b="1">
+                <a:solidFill>
+                  <a:srgbClr val="007020"/>
+                </a:solidFill>
+                <a:latin typeface="Consolas"/>
+              </a:rPr>
+              <a:t>&lt;button</a:t>
+            </a:r>
+            <a:r>
+              <a:rPr sz="900">
+                <a:solidFill>
+                  <a:srgbClr val="007020"/>
+                </a:solidFill>
+                <a:latin typeface="Consolas"/>
+              </a:rPr>
+              <a:t> data-contact-request-ajax-submit formaction=</a:t>
+            </a:r>
+            <a:r>
+              <a:rPr sz="900">
+                <a:solidFill>
+                  <a:srgbClr val="4070A0"/>
+                </a:solidFill>
+                <a:latin typeface="Consolas"/>
+              </a:rPr>
+              <a:t>"/customer/contact-requests/async/add"</a:t>
+            </a:r>
+            <a:r>
+              <a:rPr sz="900" b="1">
+                <a:solidFill>
+                  <a:srgbClr val="007020"/>
+                </a:solidFill>
+                <a:latin typeface="Consolas"/>
+              </a:rPr>
+              <a:t>&gt;</a:t>
+            </a:r>
+            <a:r>
+              <a:rPr sz="900">
+                <a:solidFill>
+                  <a:srgbClr val="2D2D2D"/>
+                </a:solidFill>
+                <a:latin typeface="Consolas"/>
+              </a:rPr>
+              <a:t>Add Contact Request</a:t>
+            </a:r>
+            <a:r>
+              <a:rPr sz="900" b="1">
+                <a:solidFill>
+                  <a:srgbClr val="007020"/>
+                </a:solidFill>
+                <a:latin typeface="Consolas"/>
+              </a:rPr>
+              <a:t>&lt;/button&gt;</a:t>
+            </a:r>
+          </a:p>
+          <a:p>
+            <a:pPr>
+              <a:spcBef>
+                <a:spcPts val="0"/>
+              </a:spcBef>
+              <a:spcAft>
+                <a:spcPts val="0"/>
+              </a:spcAft>
+            </a:pPr>
+            <a:r>
+              <a:rPr sz="900" b="1">
+                <a:solidFill>
+                  <a:srgbClr val="007020"/>
+                </a:solidFill>
+                <a:latin typeface="Consolas"/>
+              </a:rPr>
+              <a:t>&lt;button</a:t>
+            </a:r>
+            <a:r>
+              <a:rPr sz="900">
+                <a:solidFill>
+                  <a:srgbClr val="007020"/>
+                </a:solidFill>
+                <a:latin typeface="Consolas"/>
+              </a:rPr>
+              <a:t> data-contact-request-ajax-submit formaction=</a:t>
+            </a:r>
+            <a:r>
+              <a:rPr sz="900">
+                <a:solidFill>
+                  <a:srgbClr val="4070A0"/>
+                </a:solidFill>
+                <a:latin typeface="Consolas"/>
+              </a:rPr>
+              <a:t>"/customer/contact-requests/async/delete"</a:t>
+            </a:r>
+            <a:r>
+              <a:rPr sz="900" b="1">
+                <a:solidFill>
+                  <a:srgbClr val="007020"/>
+                </a:solidFill>
+                <a:latin typeface="Consolas"/>
+              </a:rPr>
+              <a:t>&gt;</a:t>
+            </a:r>
+            <a:r>
+              <a:rPr sz="900">
+                <a:solidFill>
+                  <a:srgbClr val="2D2D2D"/>
+                </a:solidFill>
+                <a:latin typeface="Consolas"/>
+              </a:rPr>
+              <a:t>Delete</a:t>
+            </a:r>
+            <a:r>
+              <a:rPr sz="900" b="1">
+                <a:solidFill>
+                  <a:srgbClr val="007020"/>
+                </a:solidFill>
+                <a:latin typeface="Consolas"/>
+              </a:rPr>
+              <a:t>&lt;/button&gt;</a:t>
+            </a:r>
+          </a:p>
+        </p:txBody>
+      </p:sp>
+    </p:spTree>
+  </p:cSld>
+  <p:clrMapOvr>
+    <a:masterClrMapping/>
+  </p:clrMapOvr>
+</p:sld>
+</file>
+
+<file path=ppt/slides/slide207.xml><?xml version="1.0" encoding="utf-8"?>
 <p:sld xmlns:a="http://schemas.openxmlformats.org/drawingml/2006/main" xmlns:p="http://schemas.openxmlformats.org/presentationml/2006/main" xmlns:r="http://schemas.openxmlformats.org/officeDocument/2006/relationships">
   <p:cSld>
     <p:spTree>

</xml_diff>

<commit_message>
docs: the add page lives at /contact-request/index/add everywhere
Guide 06b still described the duplicate ContactRequestController and its
URL, which the exercise branches no longer have. Guide 04 now names the two
tests that cover steps 3.1 and 3.2.

Co-Authored-By: Claude Opus 5 (1M context) <noreply@anthropic.com>
</commit_message>
<xml_diff>
--- a/guides-pptx/spryker-academy-fundamental.pptx
+++ b/guides-pptx/spryker-academy-fundamental.pptx
@@ -8339,6 +8339,21 @@
               </a:defRPr>
             </a:pPr>
             <a:r>
+              <a:t>AddTemplateTest checks this step, and IndexControllerAddActionTest checks the controller above it.</a:t>
+            </a:r>
+          </a:p>
+          <a:p>
+            <a:pPr>
+              <a:spcAft>
+                <a:spcPts val="800"/>
+              </a:spcAft>
+              <a:defRPr sz="1600">
+                <a:solidFill>
+                  <a:srgbClr val="1A1A1A"/>
+                </a:solidFill>
+              </a:defRPr>
+            </a:pPr>
+            <a:r>
               <a:t>Clear cache:</a:t>
             </a:r>
           </a:p>
@@ -8977,7 +8992,7 @@
               </a:defRPr>
             </a:pPr>
             <a:r>
-              <a:t>This tests the ContactRequestReader, the ContactRequestWriter and the ContactRequestFacade. All tests should pass if your implementation is correct.</a:t>
+              <a:t>This tests the ContactRequestReader, the ContactRequestWriter, the ContactRequestFacade, addAction() on the IndexController and the add.twig template. All tests should pass if your implementation is correct.</a:t>
             </a:r>
           </a:p>
         </p:txBody>
@@ -21662,26 +21677,26 @@
                 </a:solidFill>
                 <a:latin typeface="Consolas"/>
               </a:rPr>
-              <a:t>   and Communication layer (CommunicationFactory, IndexController, ContactRequestController with an add</a:t>
-            </a:r>
-          </a:p>
-          <a:p>
-            <a:pPr>
-              <a:spcBef>
-                <a:spcPts val="0"/>
-              </a:spcBef>
-              <a:spcAft>
-                <a:spcPts val="0"/>
-              </a:spcAft>
-            </a:pPr>
-            <a:r>
-              <a:rPr sz="900">
-                <a:solidFill>
-                  <a:srgbClr val="2D2D2D"/>
-                </a:solidFill>
-                <a:latin typeface="Consolas"/>
-              </a:rPr>
-              <a:t>   form page at /contact-request/contact-request/add, GatewayController).</a:t>
+              <a:t>   and Communication layer (CommunicationFactory, IndexController with indexAction() and an</a:t>
+            </a:r>
+          </a:p>
+          <a:p>
+            <a:pPr>
+              <a:spcBef>
+                <a:spcPts val="0"/>
+              </a:spcBef>
+              <a:spcAft>
+                <a:spcPts val="0"/>
+              </a:spcAft>
+            </a:pPr>
+            <a:r>
+              <a:rPr sz="900">
+                <a:solidFill>
+                  <a:srgbClr val="2D2D2D"/>
+                </a:solidFill>
+                <a:latin typeface="Consolas"/>
+              </a:rPr>
+              <a:t>   addAction() add form page at /contact-request/index/add, GatewayController).</a:t>
             </a:r>
           </a:p>
           <a:p>
@@ -22498,7 +22513,7 @@
               </a:defRPr>
             </a:pPr>
             <a:r>
-              <a:t>• http://backoffice.eu.spryker.local/contact-request/contact-request/add creates a contact request.</a:t>
+              <a:t>• http://backoffice.eu.spryker.local/contact-request/index/add creates a contact request.</a:t>
             </a:r>
           </a:p>
           <a:p>

</xml_diff>